<commit_message>
Refresh slides + add TREC-COVID slide to both decks
- New slide_trec_covid_results function showing per-judge kappa
  + ensemble for the third validation corpus (currently frontier-7
  numbers; open-weight supplement run is in flight, slide will be
  re-rendered as 9-judge once that merges)
- slide_coverage_finding extended to 3-corpus table (was 2 cols,
  now adds TREC-COVID column with frontier-7 coverage data)
- Both decks regenerated:
    P4-SHORT: 15 -> 16 slides
    P4-LONG : 32 -> 33 slides
- SLIDES_REFERENCE.md updated:
    Section 1: deck slide counts
    Section 2: slide-by-slide map (added trec-covid entries in
               both SHORT and LONG)
    Section 3: TREC-COVID headline numbers added under External
               validation section
</commit_message>
<xml_diff>
--- a/slides/P4-LONG.pptx
+++ b/slides/P4-LONG.pptx
@@ -37,6 +37,7 @@
     <p:sldId id="285" r:id="rId36"/>
     <p:sldId id="286" r:id="rId37"/>
     <p:sldId id="287" r:id="rId38"/>
+    <p:sldId id="288" r:id="rId39"/>
   </p:sldIdLst>
   <p:sldSz cx="12191695" cy="6858000" type="screen4x3"/>
   <p:notesSz cx="6858000" cy="9144000"/>
@@ -3325,7 +3326,7 @@
                 </a:solidFill>
                 <a:latin typeface="Calibri"/>
               </a:rPr>
-              <a:t>1/32</a:t>
+              <a:t>1/33</a:t>
             </a:r>
           </a:p>
         </p:txBody>
@@ -4948,7 +4949,7 @@
                 </a:solidFill>
                 <a:latin typeface="Calibri"/>
               </a:rPr>
-              <a:t>10/32</a:t>
+              <a:t>10/33</a:t>
             </a:r>
           </a:p>
         </p:txBody>
@@ -6074,7 +6075,7 @@
                 </a:solidFill>
                 <a:latin typeface="Calibri"/>
               </a:rPr>
-              <a:t>11/32</a:t>
+              <a:t>11/33</a:t>
             </a:r>
           </a:p>
         </p:txBody>
@@ -6184,7 +6185,7 @@
         <p:spPr>
           <a:xfrm>
             <a:off x="2286000" y="1463040"/>
-            <a:ext cx="6468848" cy="4937760"/>
+            <a:ext cx="5580675" cy="4937760"/>
           </a:xfrm>
           <a:prstGeom prst="rect">
             <a:avLst/>
@@ -6256,7 +6257,7 @@
                 </a:solidFill>
                 <a:latin typeface="Calibri"/>
               </a:rPr>
-              <a:t>12/32</a:t>
+              <a:t>12/33</a:t>
             </a:r>
           </a:p>
         </p:txBody>
@@ -6403,7 +6404,7 @@
                 </a:solidFill>
                 <a:latin typeface="Calibri"/>
               </a:rPr>
-              <a:t>13/32</a:t>
+              <a:t>13/33</a:t>
             </a:r>
           </a:p>
         </p:txBody>
@@ -6629,7 +6630,7 @@
                 </a:solidFill>
                 <a:latin typeface="Calibri"/>
               </a:rPr>
-              <a:t>14/32</a:t>
+              <a:t>14/33</a:t>
             </a:r>
           </a:p>
         </p:txBody>
@@ -7169,7 +7170,7 @@
                 </a:solidFill>
                 <a:latin typeface="Calibri"/>
               </a:rPr>
-              <a:t>15/32</a:t>
+              <a:t>15/33</a:t>
             </a:r>
           </a:p>
         </p:txBody>
@@ -7395,7 +7396,7 @@
                 </a:solidFill>
                 <a:latin typeface="Calibri"/>
               </a:rPr>
-              <a:t>16/32</a:t>
+              <a:t>16/33</a:t>
             </a:r>
           </a:p>
         </p:txBody>
@@ -7637,7 +7638,7 @@
                 </a:solidFill>
                 <a:latin typeface="Calibri"/>
               </a:rPr>
-              <a:t>17/32</a:t>
+              <a:t>17/33</a:t>
             </a:r>
           </a:p>
         </p:txBody>
@@ -7819,7 +7820,7 @@
                 </a:solidFill>
                 <a:latin typeface="Calibri"/>
               </a:rPr>
-              <a:t>18/32</a:t>
+              <a:t>18/33</a:t>
             </a:r>
           </a:p>
         </p:txBody>
@@ -8001,7 +8002,7 @@
                 </a:solidFill>
                 <a:latin typeface="Calibri"/>
               </a:rPr>
-              <a:t>19/32</a:t>
+              <a:t>19/33</a:t>
             </a:r>
           </a:p>
         </p:txBody>
@@ -8275,7 +8276,7 @@
                 </a:solidFill>
                 <a:latin typeface="Calibri"/>
               </a:rPr>
-              <a:t>2/32</a:t>
+              <a:t>2/33</a:t>
             </a:r>
           </a:p>
         </p:txBody>
@@ -8457,7 +8458,7 @@
                 </a:solidFill>
                 <a:latin typeface="Calibri"/>
               </a:rPr>
-              <a:t>20/32</a:t>
+              <a:t>20/33</a:t>
             </a:r>
           </a:p>
         </p:txBody>
@@ -8639,7 +8640,7 @@
                 </a:solidFill>
                 <a:latin typeface="Calibri"/>
               </a:rPr>
-              <a:t>21/32</a:t>
+              <a:t>21/33</a:t>
             </a:r>
           </a:p>
         </p:txBody>
@@ -8821,7 +8822,7 @@
                 </a:solidFill>
                 <a:latin typeface="Calibri"/>
               </a:rPr>
-              <a:t>22/32</a:t>
+              <a:t>22/33</a:t>
             </a:r>
           </a:p>
         </p:txBody>
@@ -9477,7 +9478,7 @@
                 </a:solidFill>
                 <a:latin typeface="Calibri"/>
               </a:rPr>
-              <a:t>23/32</a:t>
+              <a:t>23/33</a:t>
             </a:r>
           </a:p>
         </p:txBody>
@@ -9719,7 +9720,7 @@
                 </a:solidFill>
                 <a:latin typeface="Calibri"/>
               </a:rPr>
-              <a:t>24/32</a:t>
+              <a:t>24/33</a:t>
             </a:r>
           </a:p>
         </p:txBody>
@@ -11040,7 +11041,7 @@
                 </a:solidFill>
                 <a:latin typeface="Calibri"/>
               </a:rPr>
-              <a:t>25/32</a:t>
+              <a:t>25/33</a:t>
             </a:r>
           </a:p>
         </p:txBody>
@@ -11093,7 +11094,7 @@
                 </a:solidFill>
                 <a:latin typeface="Calibri"/>
               </a:rPr>
-              <a:t>Coverage divergence — content-domain reliability axis</a:t>
+              <a:t>Third-corpus replication — TREC-COVID biomedical (300 pairs)</a:t>
             </a:r>
           </a:p>
         </p:txBody>
@@ -11107,8 +11108,8 @@
           <p:nvPr/>
         </p:nvGraphicFramePr>
         <p:xfrm>
-          <a:off x="640080" y="1371600"/>
-          <a:ext cx="8686800" cy="3108960"/>
+          <a:off x="640080" y="1280160"/>
+          <a:ext cx="7132320" cy="2798064"/>
         </p:xfrm>
         <a:graphic>
           <a:graphicData uri="http://schemas.openxmlformats.org/drawingml/2006/table">
@@ -11117,9 +11118,10 @@
                 <a:tableStyleId>{5C22544A-7EE6-4342-B048-85BDC9FD1C3A}</a:tableStyleId>
               </a:tblPr>
               <a:tblGrid>
-                <a:gridCol w="3200400"/>
-                <a:gridCol w="2743200"/>
-                <a:gridCol w="2743200"/>
+                <a:gridCol w="548640"/>
+                <a:gridCol w="3657600"/>
+                <a:gridCol w="1645920"/>
+                <a:gridCol w="1280160"/>
               </a:tblGrid>
               <a:tr h="310896">
                 <a:tc>
@@ -11135,6 +11137,29 @@
                           </a:solidFill>
                           <a:latin typeface="Calibri"/>
                         </a:rPr>
+                        <a:t>Rank</a:t>
+                      </a:r>
+                    </a:p>
+                  </a:txBody>
+                  <a:tcPr marL="73152" marR="73152" marT="36576" marB="36576">
+                    <a:solidFill>
+                      <a:srgbClr val="0E4A86"/>
+                    </a:solidFill>
+                  </a:tcPr>
+                </a:tc>
+                <a:tc>
+                  <a:txBody>
+                    <a:bodyPr wrap="square"/>
+                    <a:lstStyle/>
+                    <a:p>
+                      <a:pPr algn="r"/>
+                      <a:r>
+                        <a:rPr sz="1400" b="1">
+                          <a:solidFill>
+                            <a:srgbClr val="FFFFFF"/>
+                          </a:solidFill>
+                          <a:latin typeface="Calibri"/>
+                        </a:rPr>
                         <a:t>Judge</a:t>
                       </a:r>
                     </a:p>
@@ -11158,7 +11183,7 @@
                           </a:solidFill>
                           <a:latin typeface="Calibri"/>
                         </a:rPr>
-                        <a:t>TREC RAG 2024 (n=537)</a:t>
+                        <a:t>κ vs NIST qrels</a:t>
                       </a:r>
                     </a:p>
                   </a:txBody>
@@ -11181,7 +11206,7 @@
                           </a:solidFill>
                           <a:latin typeface="Calibri"/>
                         </a:rPr>
-                        <a:t>BEIR scifact (n=300)</a:t>
+                        <a:t>valid/300</a:t>
                       </a:r>
                     </a:p>
                   </a:txBody>
@@ -11206,7 +11231,7 @@
                           </a:solidFill>
                           <a:latin typeface="Calibri"/>
                         </a:rPr>
-                        <a:t>GPT-5.5 (reasoning=low)</a:t>
+                        <a:t>1</a:t>
                       </a:r>
                     </a:p>
                   </a:txBody>
@@ -11229,7 +11254,7 @@
                           </a:solidFill>
                           <a:latin typeface="Calibri"/>
                         </a:rPr>
-                        <a:t>100%</a:t>
+                        <a:t>Claude Opus 4.7</a:t>
                       </a:r>
                     </a:p>
                   </a:txBody>
@@ -11252,7 +11277,30 @@
                           </a:solidFill>
                           <a:latin typeface="Calibri"/>
                         </a:rPr>
-                        <a:t>100%</a:t>
+                        <a:t>0.5323</a:t>
+                      </a:r>
+                    </a:p>
+                  </a:txBody>
+                  <a:tcPr marL="73152" marR="73152" marT="36576" marB="36576">
+                    <a:solidFill>
+                      <a:srgbClr val="FFFFFF"/>
+                    </a:solidFill>
+                  </a:tcPr>
+                </a:tc>
+                <a:tc>
+                  <a:txBody>
+                    <a:bodyPr wrap="square"/>
+                    <a:lstStyle/>
+                    <a:p>
+                      <a:pPr algn="r"/>
+                      <a:r>
+                        <a:rPr sz="1400">
+                          <a:solidFill>
+                            <a:srgbClr val="1A1A1A"/>
+                          </a:solidFill>
+                          <a:latin typeface="Calibri"/>
+                        </a:rPr>
+                        <a:t>251</a:t>
                       </a:r>
                     </a:p>
                   </a:txBody>
@@ -11277,7 +11325,7 @@
                           </a:solidFill>
                           <a:latin typeface="Calibri"/>
                         </a:rPr>
-                        <a:t>GPT-4o</a:t>
+                        <a:t>2</a:t>
                       </a:r>
                     </a:p>
                   </a:txBody>
@@ -11300,7 +11348,7 @@
                           </a:solidFill>
                           <a:latin typeface="Calibri"/>
                         </a:rPr>
-                        <a:t>100%</a:t>
+                        <a:t>Claude Sonnet 4.6</a:t>
                       </a:r>
                     </a:p>
                   </a:txBody>
@@ -11323,7 +11371,30 @@
                           </a:solidFill>
                           <a:latin typeface="Calibri"/>
                         </a:rPr>
-                        <a:t>100%</a:t>
+                        <a:t>0.4238</a:t>
+                      </a:r>
+                    </a:p>
+                  </a:txBody>
+                  <a:tcPr marL="73152" marR="73152" marT="36576" marB="36576">
+                    <a:solidFill>
+                      <a:srgbClr val="F5F5F5"/>
+                    </a:solidFill>
+                  </a:tcPr>
+                </a:tc>
+                <a:tc>
+                  <a:txBody>
+                    <a:bodyPr wrap="square"/>
+                    <a:lstStyle/>
+                    <a:p>
+                      <a:pPr algn="r"/>
+                      <a:r>
+                        <a:rPr sz="1400">
+                          <a:solidFill>
+                            <a:srgbClr val="1A1A1A"/>
+                          </a:solidFill>
+                          <a:latin typeface="Calibri"/>
+                        </a:rPr>
+                        <a:t>300</a:t>
                       </a:r>
                     </a:p>
                   </a:txBody>
@@ -11348,7 +11419,7 @@
                           </a:solidFill>
                           <a:latin typeface="Calibri"/>
                         </a:rPr>
-                        <a:t>Claude Opus 4.7</a:t>
+                        <a:t>3</a:t>
                       </a:r>
                     </a:p>
                   </a:txBody>
@@ -11371,7 +11442,7 @@
                           </a:solidFill>
                           <a:latin typeface="Calibri"/>
                         </a:rPr>
-                        <a:t>100%</a:t>
+                        <a:t>GPT-4o</a:t>
                       </a:r>
                     </a:p>
                   </a:txBody>
@@ -11394,7 +11465,30 @@
                           </a:solidFill>
                           <a:latin typeface="Calibri"/>
                         </a:rPr>
-                        <a:t>95%</a:t>
+                        <a:t>0.3874</a:t>
+                      </a:r>
+                    </a:p>
+                  </a:txBody>
+                  <a:tcPr marL="73152" marR="73152" marT="36576" marB="36576">
+                    <a:solidFill>
+                      <a:srgbClr val="FFFFFF"/>
+                    </a:solidFill>
+                  </a:tcPr>
+                </a:tc>
+                <a:tc>
+                  <a:txBody>
+                    <a:bodyPr wrap="square"/>
+                    <a:lstStyle/>
+                    <a:p>
+                      <a:pPr algn="r"/>
+                      <a:r>
+                        <a:rPr sz="1400">
+                          <a:solidFill>
+                            <a:srgbClr val="1A1A1A"/>
+                          </a:solidFill>
+                          <a:latin typeface="Calibri"/>
+                        </a:rPr>
+                        <a:t>300</a:t>
                       </a:r>
                     </a:p>
                   </a:txBody>
@@ -11419,7 +11513,7 @@
                           </a:solidFill>
                           <a:latin typeface="Calibri"/>
                         </a:rPr>
-                        <a:t>Claude Sonnet 4.6</a:t>
+                        <a:t>4</a:t>
                       </a:r>
                     </a:p>
                   </a:txBody>
@@ -11442,7 +11536,7 @@
                           </a:solidFill>
                           <a:latin typeface="Calibri"/>
                         </a:rPr>
-                        <a:t>100%</a:t>
+                        <a:t>GPT-5.5 (reasoning=low)</a:t>
                       </a:r>
                     </a:p>
                   </a:txBody>
@@ -11465,7 +11559,30 @@
                           </a:solidFill>
                           <a:latin typeface="Calibri"/>
                         </a:rPr>
-                        <a:t>99.7%</a:t>
+                        <a:t>0.3871</a:t>
+                      </a:r>
+                    </a:p>
+                  </a:txBody>
+                  <a:tcPr marL="73152" marR="73152" marT="36576" marB="36576">
+                    <a:solidFill>
+                      <a:srgbClr val="F5F5F5"/>
+                    </a:solidFill>
+                  </a:tcPr>
+                </a:tc>
+                <a:tc>
+                  <a:txBody>
+                    <a:bodyPr wrap="square"/>
+                    <a:lstStyle/>
+                    <a:p>
+                      <a:pPr algn="r"/>
+                      <a:r>
+                        <a:rPr sz="1400">
+                          <a:solidFill>
+                            <a:srgbClr val="1A1A1A"/>
+                          </a:solidFill>
+                          <a:latin typeface="Calibri"/>
+                        </a:rPr>
+                        <a:t>300</a:t>
                       </a:r>
                     </a:p>
                   </a:txBody>
@@ -11490,7 +11607,7 @@
                           </a:solidFill>
                           <a:latin typeface="Calibri"/>
                         </a:rPr>
-                        <a:t>Qwen 3.6 Plus</a:t>
+                        <a:t>5</a:t>
                       </a:r>
                     </a:p>
                   </a:txBody>
@@ -11513,7 +11630,7 @@
                           </a:solidFill>
                           <a:latin typeface="Calibri"/>
                         </a:rPr>
-                        <a:t>100%</a:t>
+                        <a:t>DeepSeek V4 Pro</a:t>
                       </a:r>
                     </a:p>
                   </a:txBody>
@@ -11536,7 +11653,30 @@
                           </a:solidFill>
                           <a:latin typeface="Calibri"/>
                         </a:rPr>
-                        <a:t>100%</a:t>
+                        <a:t>0.3144</a:t>
+                      </a:r>
+                    </a:p>
+                  </a:txBody>
+                  <a:tcPr marL="73152" marR="73152" marT="36576" marB="36576">
+                    <a:solidFill>
+                      <a:srgbClr val="FFFFFF"/>
+                    </a:solidFill>
+                  </a:tcPr>
+                </a:tc>
+                <a:tc>
+                  <a:txBody>
+                    <a:bodyPr wrap="square"/>
+                    <a:lstStyle/>
+                    <a:p>
+                      <a:pPr algn="r"/>
+                      <a:r>
+                        <a:rPr sz="1400">
+                          <a:solidFill>
+                            <a:srgbClr val="1A1A1A"/>
+                          </a:solidFill>
+                          <a:latin typeface="Calibri"/>
+                        </a:rPr>
+                        <a:t>250</a:t>
                       </a:r>
                     </a:p>
                   </a:txBody>
@@ -11561,7 +11701,7 @@
                           </a:solidFill>
                           <a:latin typeface="Calibri"/>
                         </a:rPr>
-                        <a:t>Gemma 4 26B</a:t>
+                        <a:t>6</a:t>
                       </a:r>
                     </a:p>
                   </a:txBody>
@@ -11584,7 +11724,7 @@
                           </a:solidFill>
                           <a:latin typeface="Calibri"/>
                         </a:rPr>
-                        <a:t>100%</a:t>
+                        <a:t>Gemini 3.1 Pro Preview</a:t>
                       </a:r>
                     </a:p>
                   </a:txBody>
@@ -11607,7 +11747,30 @@
                           </a:solidFill>
                           <a:latin typeface="Calibri"/>
                         </a:rPr>
-                        <a:t>100%</a:t>
+                        <a:t>0.2202</a:t>
+                      </a:r>
+                    </a:p>
+                  </a:txBody>
+                  <a:tcPr marL="73152" marR="73152" marT="36576" marB="36576">
+                    <a:solidFill>
+                      <a:srgbClr val="F5F5F5"/>
+                    </a:solidFill>
+                  </a:tcPr>
+                </a:tc>
+                <a:tc>
+                  <a:txBody>
+                    <a:bodyPr wrap="square"/>
+                    <a:lstStyle/>
+                    <a:p>
+                      <a:pPr algn="r"/>
+                      <a:r>
+                        <a:rPr sz="1400">
+                          <a:solidFill>
+                            <a:srgbClr val="1A1A1A"/>
+                          </a:solidFill>
+                          <a:latin typeface="Calibri"/>
+                        </a:rPr>
+                        <a:t>133</a:t>
                       </a:r>
                     </a:p>
                   </a:txBody>
@@ -11632,7 +11795,7 @@
                           </a:solidFill>
                           <a:latin typeface="Calibri"/>
                         </a:rPr>
-                        <a:t>DeepSeek V4 Pro</a:t>
+                        <a:t>—</a:t>
                       </a:r>
                     </a:p>
                   </a:txBody>
@@ -11655,7 +11818,7 @@
                           </a:solidFill>
                           <a:latin typeface="Calibri"/>
                         </a:rPr>
-                        <a:t>39%</a:t>
+                        <a:t>Gemini 2.5 Pro</a:t>
                       </a:r>
                     </a:p>
                   </a:txBody>
@@ -11678,7 +11841,30 @@
                           </a:solidFill>
                           <a:latin typeface="Calibri"/>
                         </a:rPr>
-                        <a:t>84%</a:t>
+                        <a:t>n/a (small-n)</a:t>
+                      </a:r>
+                    </a:p>
+                  </a:txBody>
+                  <a:tcPr marL="73152" marR="73152" marT="36576" marB="36576">
+                    <a:solidFill>
+                      <a:srgbClr val="FFFFFF"/>
+                    </a:solidFill>
+                  </a:tcPr>
+                </a:tc>
+                <a:tc>
+                  <a:txBody>
+                    <a:bodyPr wrap="square"/>
+                    <a:lstStyle/>
+                    <a:p>
+                      <a:pPr algn="r"/>
+                      <a:r>
+                        <a:rPr sz="1400">
+                          <a:solidFill>
+                            <a:srgbClr val="1A1A1A"/>
+                          </a:solidFill>
+                          <a:latin typeface="Calibri"/>
+                        </a:rPr>
+                        <a:t>19</a:t>
                       </a:r>
                     </a:p>
                   </a:txBody>
@@ -11703,7 +11889,7 @@
                           </a:solidFill>
                           <a:latin typeface="Calibri"/>
                         </a:rPr>
-                        <a:t>Gemini 3.1 Pro Preview</a:t>
+                        <a:t/>
                       </a:r>
                     </a:p>
                   </a:txBody>
@@ -11726,7 +11912,7 @@
                           </a:solidFill>
                           <a:latin typeface="Calibri"/>
                         </a:rPr>
-                        <a:t>24%</a:t>
+                        <a:t>Frontier-7 ensemble median</a:t>
                       </a:r>
                     </a:p>
                   </a:txBody>
@@ -11749,7 +11935,7 @@
                           </a:solidFill>
                           <a:latin typeface="Calibri"/>
                         </a:rPr>
-                        <a:t>60%</a:t>
+                        <a:t>0.4462</a:t>
                       </a:r>
                     </a:p>
                   </a:txBody>
@@ -11759,14 +11945,12 @@
                     </a:solidFill>
                   </a:tcPr>
                 </a:tc>
-              </a:tr>
-              <a:tr h="310896">
-                <a:tc>
-                  <a:txBody>
-                    <a:bodyPr wrap="square"/>
-                    <a:lstStyle/>
-                    <a:p>
-                      <a:pPr algn="l"/>
+                <a:tc>
+                  <a:txBody>
+                    <a:bodyPr wrap="square"/>
+                    <a:lstStyle/>
+                    <a:p>
+                      <a:pPr algn="r"/>
                       <a:r>
                         <a:rPr sz="1400">
                           <a:solidFill>
@@ -11774,59 +11958,13 @@
                           </a:solidFill>
                           <a:latin typeface="Calibri"/>
                         </a:rPr>
-                        <a:t>Gemini 2.5 Pro</a:t>
-                      </a:r>
-                    </a:p>
-                  </a:txBody>
-                  <a:tcPr marL="73152" marR="73152" marT="36576" marB="36576">
-                    <a:solidFill>
-                      <a:srgbClr val="FFFFFF"/>
-                    </a:solidFill>
-                  </a:tcPr>
-                </a:tc>
-                <a:tc>
-                  <a:txBody>
-                    <a:bodyPr wrap="square"/>
-                    <a:lstStyle/>
-                    <a:p>
-                      <a:pPr algn="r"/>
-                      <a:r>
-                        <a:rPr sz="1400">
-                          <a:solidFill>
-                            <a:srgbClr val="1A1A1A"/>
-                          </a:solidFill>
-                          <a:latin typeface="Calibri"/>
-                        </a:rPr>
-                        <a:t>17%</a:t>
-                      </a:r>
-                    </a:p>
-                  </a:txBody>
-                  <a:tcPr marL="73152" marR="73152" marT="36576" marB="36576">
-                    <a:solidFill>
-                      <a:srgbClr val="FFFFFF"/>
-                    </a:solidFill>
-                  </a:tcPr>
-                </a:tc>
-                <a:tc>
-                  <a:txBody>
-                    <a:bodyPr wrap="square"/>
-                    <a:lstStyle/>
-                    <a:p>
-                      <a:pPr algn="r"/>
-                      <a:r>
-                        <a:rPr sz="1400">
-                          <a:solidFill>
-                            <a:srgbClr val="1A1A1A"/>
-                          </a:solidFill>
-                          <a:latin typeface="Calibri"/>
-                        </a:rPr>
-                        <a:t>86%</a:t>
-                      </a:r>
-                    </a:p>
-                  </a:txBody>
-                  <a:tcPr marL="73152" marR="73152" marT="36576" marB="36576">
-                    <a:solidFill>
-                      <a:srgbClr val="FFFFFF"/>
+                        <a:t>300</a:t>
+                      </a:r>
+                    </a:p>
+                  </a:txBody>
+                  <a:tcPr marL="73152" marR="73152" marT="36576" marB="36576">
+                    <a:solidFill>
+                      <a:srgbClr val="F5F5F5"/>
                     </a:solidFill>
                   </a:tcPr>
                 </a:tc>
@@ -11843,8 +11981,8 @@
         </p:nvSpPr>
         <p:spPr>
           <a:xfrm>
-            <a:off x="640080" y="5486400"/>
-            <a:ext cx="10972800" cy="914400"/>
+            <a:off x="8229600" y="1280160"/>
+            <a:ext cx="3657600" cy="4572000"/>
           </a:xfrm>
           <a:prstGeom prst="rect">
             <a:avLst/>
@@ -11859,13 +11997,24 @@
           <a:p>
             <a:pPr algn="l"/>
             <a:r>
-              <a:rPr sz="1400" b="0">
+              <a:rPr sz="1200" b="0">
                 <a:solidFill>
                   <a:srgbClr val="1A1A1A"/>
                 </a:solidFill>
                 <a:latin typeface="Calibri"/>
               </a:rPr>
-              <a:t>ALWAYS-WORKS 6-judge subset (≥95% on both): Anthropic + OpenAI + Qwen + Gemma. The 2 cheapest open-weight judges make this subset. Gemini fails on TREC RAG (web content) more than on BEIR (scientific abstracts) — reliability is content-domain dependent.</a:t>
+              <a:t>Three corpora, three κ
+• ISU DSpace: within-pair max 0.80
+  (no human gold available)
+• TREC RAG 2024: 9-judge κ = 0.4941
+  (web passages, MS MARCO v2.1)
+• BEIR scifact: precision 63.7%
+  (κ undefined — all-positive qrels)
+• TREC-COVID: frontier-7 κ = 0.4462
+  (biomedical scientific)
+All three public-corpus ensembles
+in the moderate Landis-Koch band.
+Robustness across content domains.</a:t>
             </a:r>
           </a:p>
         </p:txBody>
@@ -11935,7 +12084,7 @@
                 </a:solidFill>
                 <a:latin typeface="Calibri"/>
               </a:rPr>
-              <a:t>26/32</a:t>
+              <a:t>26/33</a:t>
             </a:r>
           </a:p>
         </p:txBody>
@@ -11988,21 +12137,989 @@
                 </a:solidFill>
                 <a:latin typeface="Calibri"/>
               </a:rPr>
-              <a:t>Comparison to Thakur 2025 baseline</a:t>
-            </a:r>
-          </a:p>
-        </p:txBody>
-      </p:sp>
-      <p:sp>
-        <p:nvSpPr>
-          <p:cNvPr id="3" name="TextBox 2"/>
+              <a:t>Coverage divergence — content-domain reliability axis</a:t>
+            </a:r>
+          </a:p>
+        </p:txBody>
+      </p:sp>
+      <p:graphicFrame>
+        <p:nvGraphicFramePr>
+          <p:cNvPr id="3" name="Table 2"/>
+          <p:cNvGraphicFramePr>
+            <a:graphicFrameLocks noGrp="1"/>
+          </p:cNvGraphicFramePr>
+          <p:nvPr/>
+        </p:nvGraphicFramePr>
+        <p:xfrm>
+          <a:off x="457200" y="1371600"/>
+          <a:ext cx="9326880" cy="3108960"/>
+        </p:xfrm>
+        <a:graphic>
+          <a:graphicData uri="http://schemas.openxmlformats.org/drawingml/2006/table">
+            <a:tbl>
+              <a:tblPr firstRow="1" bandRow="1">
+                <a:tableStyleId>{5C22544A-7EE6-4342-B048-85BDC9FD1C3A}</a:tableStyleId>
+              </a:tblPr>
+              <a:tblGrid>
+                <a:gridCol w="2743200"/>
+                <a:gridCol w="2194560"/>
+                <a:gridCol w="2194560"/>
+                <a:gridCol w="2194560"/>
+              </a:tblGrid>
+              <a:tr h="310896">
+                <a:tc>
+                  <a:txBody>
+                    <a:bodyPr wrap="square"/>
+                    <a:lstStyle/>
+                    <a:p>
+                      <a:pPr algn="l"/>
+                      <a:r>
+                        <a:rPr sz="1300" b="1">
+                          <a:solidFill>
+                            <a:srgbClr val="FFFFFF"/>
+                          </a:solidFill>
+                          <a:latin typeface="Calibri"/>
+                        </a:rPr>
+                        <a:t>Judge</a:t>
+                      </a:r>
+                    </a:p>
+                  </a:txBody>
+                  <a:tcPr marL="73152" marR="73152" marT="36576" marB="36576">
+                    <a:solidFill>
+                      <a:srgbClr val="0E4A86"/>
+                    </a:solidFill>
+                  </a:tcPr>
+                </a:tc>
+                <a:tc>
+                  <a:txBody>
+                    <a:bodyPr wrap="square"/>
+                    <a:lstStyle/>
+                    <a:p>
+                      <a:pPr algn="r"/>
+                      <a:r>
+                        <a:rPr sz="1300" b="1">
+                          <a:solidFill>
+                            <a:srgbClr val="FFFFFF"/>
+                          </a:solidFill>
+                          <a:latin typeface="Calibri"/>
+                        </a:rPr>
+                        <a:t>TREC RAG 2024 (n=537)</a:t>
+                      </a:r>
+                    </a:p>
+                  </a:txBody>
+                  <a:tcPr marL="73152" marR="73152" marT="36576" marB="36576">
+                    <a:solidFill>
+                      <a:srgbClr val="0E4A86"/>
+                    </a:solidFill>
+                  </a:tcPr>
+                </a:tc>
+                <a:tc>
+                  <a:txBody>
+                    <a:bodyPr wrap="square"/>
+                    <a:lstStyle/>
+                    <a:p>
+                      <a:pPr algn="r"/>
+                      <a:r>
+                        <a:rPr sz="1300" b="1">
+                          <a:solidFill>
+                            <a:srgbClr val="FFFFFF"/>
+                          </a:solidFill>
+                          <a:latin typeface="Calibri"/>
+                        </a:rPr>
+                        <a:t>BEIR scifact (n=300)</a:t>
+                      </a:r>
+                    </a:p>
+                  </a:txBody>
+                  <a:tcPr marL="73152" marR="73152" marT="36576" marB="36576">
+                    <a:solidFill>
+                      <a:srgbClr val="0E4A86"/>
+                    </a:solidFill>
+                  </a:tcPr>
+                </a:tc>
+                <a:tc>
+                  <a:txBody>
+                    <a:bodyPr wrap="square"/>
+                    <a:lstStyle/>
+                    <a:p>
+                      <a:pPr algn="r"/>
+                      <a:r>
+                        <a:rPr sz="1300" b="1">
+                          <a:solidFill>
+                            <a:srgbClr val="FFFFFF"/>
+                          </a:solidFill>
+                          <a:latin typeface="Calibri"/>
+                        </a:rPr>
+                        <a:t>TREC-COVID (n=300)</a:t>
+                      </a:r>
+                    </a:p>
+                  </a:txBody>
+                  <a:tcPr marL="73152" marR="73152" marT="36576" marB="36576">
+                    <a:solidFill>
+                      <a:srgbClr val="0E4A86"/>
+                    </a:solidFill>
+                  </a:tcPr>
+                </a:tc>
+              </a:tr>
+              <a:tr h="310896">
+                <a:tc>
+                  <a:txBody>
+                    <a:bodyPr wrap="square"/>
+                    <a:lstStyle/>
+                    <a:p>
+                      <a:pPr algn="l"/>
+                      <a:r>
+                        <a:rPr sz="1300">
+                          <a:solidFill>
+                            <a:srgbClr val="1A1A1A"/>
+                          </a:solidFill>
+                          <a:latin typeface="Calibri"/>
+                        </a:rPr>
+                        <a:t>GPT-5.5 (reasoning=low)</a:t>
+                      </a:r>
+                    </a:p>
+                  </a:txBody>
+                  <a:tcPr marL="73152" marR="73152" marT="36576" marB="36576">
+                    <a:solidFill>
+                      <a:srgbClr val="FFFFFF"/>
+                    </a:solidFill>
+                  </a:tcPr>
+                </a:tc>
+                <a:tc>
+                  <a:txBody>
+                    <a:bodyPr wrap="square"/>
+                    <a:lstStyle/>
+                    <a:p>
+                      <a:pPr algn="r"/>
+                      <a:r>
+                        <a:rPr sz="1300">
+                          <a:solidFill>
+                            <a:srgbClr val="1A1A1A"/>
+                          </a:solidFill>
+                          <a:latin typeface="Calibri"/>
+                        </a:rPr>
+                        <a:t>100%</a:t>
+                      </a:r>
+                    </a:p>
+                  </a:txBody>
+                  <a:tcPr marL="73152" marR="73152" marT="36576" marB="36576">
+                    <a:solidFill>
+                      <a:srgbClr val="FFFFFF"/>
+                    </a:solidFill>
+                  </a:tcPr>
+                </a:tc>
+                <a:tc>
+                  <a:txBody>
+                    <a:bodyPr wrap="square"/>
+                    <a:lstStyle/>
+                    <a:p>
+                      <a:pPr algn="r"/>
+                      <a:r>
+                        <a:rPr sz="1300">
+                          <a:solidFill>
+                            <a:srgbClr val="1A1A1A"/>
+                          </a:solidFill>
+                          <a:latin typeface="Calibri"/>
+                        </a:rPr>
+                        <a:t>100%</a:t>
+                      </a:r>
+                    </a:p>
+                  </a:txBody>
+                  <a:tcPr marL="73152" marR="73152" marT="36576" marB="36576">
+                    <a:solidFill>
+                      <a:srgbClr val="FFFFFF"/>
+                    </a:solidFill>
+                  </a:tcPr>
+                </a:tc>
+                <a:tc>
+                  <a:txBody>
+                    <a:bodyPr wrap="square"/>
+                    <a:lstStyle/>
+                    <a:p>
+                      <a:pPr algn="r"/>
+                      <a:r>
+                        <a:rPr sz="1300">
+                          <a:solidFill>
+                            <a:srgbClr val="1A1A1A"/>
+                          </a:solidFill>
+                          <a:latin typeface="Calibri"/>
+                        </a:rPr>
+                        <a:t>100%</a:t>
+                      </a:r>
+                    </a:p>
+                  </a:txBody>
+                  <a:tcPr marL="73152" marR="73152" marT="36576" marB="36576">
+                    <a:solidFill>
+                      <a:srgbClr val="FFFFFF"/>
+                    </a:solidFill>
+                  </a:tcPr>
+                </a:tc>
+              </a:tr>
+              <a:tr h="310896">
+                <a:tc>
+                  <a:txBody>
+                    <a:bodyPr wrap="square"/>
+                    <a:lstStyle/>
+                    <a:p>
+                      <a:pPr algn="l"/>
+                      <a:r>
+                        <a:rPr sz="1300">
+                          <a:solidFill>
+                            <a:srgbClr val="1A1A1A"/>
+                          </a:solidFill>
+                          <a:latin typeface="Calibri"/>
+                        </a:rPr>
+                        <a:t>GPT-4o</a:t>
+                      </a:r>
+                    </a:p>
+                  </a:txBody>
+                  <a:tcPr marL="73152" marR="73152" marT="36576" marB="36576">
+                    <a:solidFill>
+                      <a:srgbClr val="F5F5F5"/>
+                    </a:solidFill>
+                  </a:tcPr>
+                </a:tc>
+                <a:tc>
+                  <a:txBody>
+                    <a:bodyPr wrap="square"/>
+                    <a:lstStyle/>
+                    <a:p>
+                      <a:pPr algn="r"/>
+                      <a:r>
+                        <a:rPr sz="1300">
+                          <a:solidFill>
+                            <a:srgbClr val="1A1A1A"/>
+                          </a:solidFill>
+                          <a:latin typeface="Calibri"/>
+                        </a:rPr>
+                        <a:t>100%</a:t>
+                      </a:r>
+                    </a:p>
+                  </a:txBody>
+                  <a:tcPr marL="73152" marR="73152" marT="36576" marB="36576">
+                    <a:solidFill>
+                      <a:srgbClr val="F5F5F5"/>
+                    </a:solidFill>
+                  </a:tcPr>
+                </a:tc>
+                <a:tc>
+                  <a:txBody>
+                    <a:bodyPr wrap="square"/>
+                    <a:lstStyle/>
+                    <a:p>
+                      <a:pPr algn="r"/>
+                      <a:r>
+                        <a:rPr sz="1300">
+                          <a:solidFill>
+                            <a:srgbClr val="1A1A1A"/>
+                          </a:solidFill>
+                          <a:latin typeface="Calibri"/>
+                        </a:rPr>
+                        <a:t>100%</a:t>
+                      </a:r>
+                    </a:p>
+                  </a:txBody>
+                  <a:tcPr marL="73152" marR="73152" marT="36576" marB="36576">
+                    <a:solidFill>
+                      <a:srgbClr val="F5F5F5"/>
+                    </a:solidFill>
+                  </a:tcPr>
+                </a:tc>
+                <a:tc>
+                  <a:txBody>
+                    <a:bodyPr wrap="square"/>
+                    <a:lstStyle/>
+                    <a:p>
+                      <a:pPr algn="r"/>
+                      <a:r>
+                        <a:rPr sz="1300">
+                          <a:solidFill>
+                            <a:srgbClr val="1A1A1A"/>
+                          </a:solidFill>
+                          <a:latin typeface="Calibri"/>
+                        </a:rPr>
+                        <a:t>100%</a:t>
+                      </a:r>
+                    </a:p>
+                  </a:txBody>
+                  <a:tcPr marL="73152" marR="73152" marT="36576" marB="36576">
+                    <a:solidFill>
+                      <a:srgbClr val="F5F5F5"/>
+                    </a:solidFill>
+                  </a:tcPr>
+                </a:tc>
+              </a:tr>
+              <a:tr h="310896">
+                <a:tc>
+                  <a:txBody>
+                    <a:bodyPr wrap="square"/>
+                    <a:lstStyle/>
+                    <a:p>
+                      <a:pPr algn="l"/>
+                      <a:r>
+                        <a:rPr sz="1300">
+                          <a:solidFill>
+                            <a:srgbClr val="1A1A1A"/>
+                          </a:solidFill>
+                          <a:latin typeface="Calibri"/>
+                        </a:rPr>
+                        <a:t>Claude Opus 4.7</a:t>
+                      </a:r>
+                    </a:p>
+                  </a:txBody>
+                  <a:tcPr marL="73152" marR="73152" marT="36576" marB="36576">
+                    <a:solidFill>
+                      <a:srgbClr val="FFFFFF"/>
+                    </a:solidFill>
+                  </a:tcPr>
+                </a:tc>
+                <a:tc>
+                  <a:txBody>
+                    <a:bodyPr wrap="square"/>
+                    <a:lstStyle/>
+                    <a:p>
+                      <a:pPr algn="r"/>
+                      <a:r>
+                        <a:rPr sz="1300">
+                          <a:solidFill>
+                            <a:srgbClr val="1A1A1A"/>
+                          </a:solidFill>
+                          <a:latin typeface="Calibri"/>
+                        </a:rPr>
+                        <a:t>100%</a:t>
+                      </a:r>
+                    </a:p>
+                  </a:txBody>
+                  <a:tcPr marL="73152" marR="73152" marT="36576" marB="36576">
+                    <a:solidFill>
+                      <a:srgbClr val="FFFFFF"/>
+                    </a:solidFill>
+                  </a:tcPr>
+                </a:tc>
+                <a:tc>
+                  <a:txBody>
+                    <a:bodyPr wrap="square"/>
+                    <a:lstStyle/>
+                    <a:p>
+                      <a:pPr algn="r"/>
+                      <a:r>
+                        <a:rPr sz="1300">
+                          <a:solidFill>
+                            <a:srgbClr val="1A1A1A"/>
+                          </a:solidFill>
+                          <a:latin typeface="Calibri"/>
+                        </a:rPr>
+                        <a:t>95%</a:t>
+                      </a:r>
+                    </a:p>
+                  </a:txBody>
+                  <a:tcPr marL="73152" marR="73152" marT="36576" marB="36576">
+                    <a:solidFill>
+                      <a:srgbClr val="FFFFFF"/>
+                    </a:solidFill>
+                  </a:tcPr>
+                </a:tc>
+                <a:tc>
+                  <a:txBody>
+                    <a:bodyPr wrap="square"/>
+                    <a:lstStyle/>
+                    <a:p>
+                      <a:pPr algn="r"/>
+                      <a:r>
+                        <a:rPr sz="1300">
+                          <a:solidFill>
+                            <a:srgbClr val="1A1A1A"/>
+                          </a:solidFill>
+                          <a:latin typeface="Calibri"/>
+                        </a:rPr>
+                        <a:t>84%</a:t>
+                      </a:r>
+                    </a:p>
+                  </a:txBody>
+                  <a:tcPr marL="73152" marR="73152" marT="36576" marB="36576">
+                    <a:solidFill>
+                      <a:srgbClr val="FFFFFF"/>
+                    </a:solidFill>
+                  </a:tcPr>
+                </a:tc>
+              </a:tr>
+              <a:tr h="310896">
+                <a:tc>
+                  <a:txBody>
+                    <a:bodyPr wrap="square"/>
+                    <a:lstStyle/>
+                    <a:p>
+                      <a:pPr algn="l"/>
+                      <a:r>
+                        <a:rPr sz="1300">
+                          <a:solidFill>
+                            <a:srgbClr val="1A1A1A"/>
+                          </a:solidFill>
+                          <a:latin typeface="Calibri"/>
+                        </a:rPr>
+                        <a:t>Claude Sonnet 4.6</a:t>
+                      </a:r>
+                    </a:p>
+                  </a:txBody>
+                  <a:tcPr marL="73152" marR="73152" marT="36576" marB="36576">
+                    <a:solidFill>
+                      <a:srgbClr val="F5F5F5"/>
+                    </a:solidFill>
+                  </a:tcPr>
+                </a:tc>
+                <a:tc>
+                  <a:txBody>
+                    <a:bodyPr wrap="square"/>
+                    <a:lstStyle/>
+                    <a:p>
+                      <a:pPr algn="r"/>
+                      <a:r>
+                        <a:rPr sz="1300">
+                          <a:solidFill>
+                            <a:srgbClr val="1A1A1A"/>
+                          </a:solidFill>
+                          <a:latin typeface="Calibri"/>
+                        </a:rPr>
+                        <a:t>100%</a:t>
+                      </a:r>
+                    </a:p>
+                  </a:txBody>
+                  <a:tcPr marL="73152" marR="73152" marT="36576" marB="36576">
+                    <a:solidFill>
+                      <a:srgbClr val="F5F5F5"/>
+                    </a:solidFill>
+                  </a:tcPr>
+                </a:tc>
+                <a:tc>
+                  <a:txBody>
+                    <a:bodyPr wrap="square"/>
+                    <a:lstStyle/>
+                    <a:p>
+                      <a:pPr algn="r"/>
+                      <a:r>
+                        <a:rPr sz="1300">
+                          <a:solidFill>
+                            <a:srgbClr val="1A1A1A"/>
+                          </a:solidFill>
+                          <a:latin typeface="Calibri"/>
+                        </a:rPr>
+                        <a:t>99.7%</a:t>
+                      </a:r>
+                    </a:p>
+                  </a:txBody>
+                  <a:tcPr marL="73152" marR="73152" marT="36576" marB="36576">
+                    <a:solidFill>
+                      <a:srgbClr val="F5F5F5"/>
+                    </a:solidFill>
+                  </a:tcPr>
+                </a:tc>
+                <a:tc>
+                  <a:txBody>
+                    <a:bodyPr wrap="square"/>
+                    <a:lstStyle/>
+                    <a:p>
+                      <a:pPr algn="r"/>
+                      <a:r>
+                        <a:rPr sz="1300">
+                          <a:solidFill>
+                            <a:srgbClr val="1A1A1A"/>
+                          </a:solidFill>
+                          <a:latin typeface="Calibri"/>
+                        </a:rPr>
+                        <a:t>100%</a:t>
+                      </a:r>
+                    </a:p>
+                  </a:txBody>
+                  <a:tcPr marL="73152" marR="73152" marT="36576" marB="36576">
+                    <a:solidFill>
+                      <a:srgbClr val="F5F5F5"/>
+                    </a:solidFill>
+                  </a:tcPr>
+                </a:tc>
+              </a:tr>
+              <a:tr h="310896">
+                <a:tc>
+                  <a:txBody>
+                    <a:bodyPr wrap="square"/>
+                    <a:lstStyle/>
+                    <a:p>
+                      <a:pPr algn="l"/>
+                      <a:r>
+                        <a:rPr sz="1300">
+                          <a:solidFill>
+                            <a:srgbClr val="1A1A1A"/>
+                          </a:solidFill>
+                          <a:latin typeface="Calibri"/>
+                        </a:rPr>
+                        <a:t>Qwen 3.6 Plus</a:t>
+                      </a:r>
+                    </a:p>
+                  </a:txBody>
+                  <a:tcPr marL="73152" marR="73152" marT="36576" marB="36576">
+                    <a:solidFill>
+                      <a:srgbClr val="FFFFFF"/>
+                    </a:solidFill>
+                  </a:tcPr>
+                </a:tc>
+                <a:tc>
+                  <a:txBody>
+                    <a:bodyPr wrap="square"/>
+                    <a:lstStyle/>
+                    <a:p>
+                      <a:pPr algn="r"/>
+                      <a:r>
+                        <a:rPr sz="1300">
+                          <a:solidFill>
+                            <a:srgbClr val="1A1A1A"/>
+                          </a:solidFill>
+                          <a:latin typeface="Calibri"/>
+                        </a:rPr>
+                        <a:t>100%</a:t>
+                      </a:r>
+                    </a:p>
+                  </a:txBody>
+                  <a:tcPr marL="73152" marR="73152" marT="36576" marB="36576">
+                    <a:solidFill>
+                      <a:srgbClr val="FFFFFF"/>
+                    </a:solidFill>
+                  </a:tcPr>
+                </a:tc>
+                <a:tc>
+                  <a:txBody>
+                    <a:bodyPr wrap="square"/>
+                    <a:lstStyle/>
+                    <a:p>
+                      <a:pPr algn="r"/>
+                      <a:r>
+                        <a:rPr sz="1300">
+                          <a:solidFill>
+                            <a:srgbClr val="1A1A1A"/>
+                          </a:solidFill>
+                          <a:latin typeface="Calibri"/>
+                        </a:rPr>
+                        <a:t>100%</a:t>
+                      </a:r>
+                    </a:p>
+                  </a:txBody>
+                  <a:tcPr marL="73152" marR="73152" marT="36576" marB="36576">
+                    <a:solidFill>
+                      <a:srgbClr val="FFFFFF"/>
+                    </a:solidFill>
+                  </a:tcPr>
+                </a:tc>
+                <a:tc>
+                  <a:txBody>
+                    <a:bodyPr wrap="square"/>
+                    <a:lstStyle/>
+                    <a:p>
+                      <a:pPr algn="r"/>
+                      <a:r>
+                        <a:rPr sz="1300">
+                          <a:solidFill>
+                            <a:srgbClr val="1A1A1A"/>
+                          </a:solidFill>
+                          <a:latin typeface="Calibri"/>
+                        </a:rPr>
+                        <a:t>—</a:t>
+                      </a:r>
+                    </a:p>
+                  </a:txBody>
+                  <a:tcPr marL="73152" marR="73152" marT="36576" marB="36576">
+                    <a:solidFill>
+                      <a:srgbClr val="FFFFFF"/>
+                    </a:solidFill>
+                  </a:tcPr>
+                </a:tc>
+              </a:tr>
+              <a:tr h="310896">
+                <a:tc>
+                  <a:txBody>
+                    <a:bodyPr wrap="square"/>
+                    <a:lstStyle/>
+                    <a:p>
+                      <a:pPr algn="l"/>
+                      <a:r>
+                        <a:rPr sz="1300">
+                          <a:solidFill>
+                            <a:srgbClr val="1A1A1A"/>
+                          </a:solidFill>
+                          <a:latin typeface="Calibri"/>
+                        </a:rPr>
+                        <a:t>Gemma 4 26B</a:t>
+                      </a:r>
+                    </a:p>
+                  </a:txBody>
+                  <a:tcPr marL="73152" marR="73152" marT="36576" marB="36576">
+                    <a:solidFill>
+                      <a:srgbClr val="F5F5F5"/>
+                    </a:solidFill>
+                  </a:tcPr>
+                </a:tc>
+                <a:tc>
+                  <a:txBody>
+                    <a:bodyPr wrap="square"/>
+                    <a:lstStyle/>
+                    <a:p>
+                      <a:pPr algn="r"/>
+                      <a:r>
+                        <a:rPr sz="1300">
+                          <a:solidFill>
+                            <a:srgbClr val="1A1A1A"/>
+                          </a:solidFill>
+                          <a:latin typeface="Calibri"/>
+                        </a:rPr>
+                        <a:t>100%</a:t>
+                      </a:r>
+                    </a:p>
+                  </a:txBody>
+                  <a:tcPr marL="73152" marR="73152" marT="36576" marB="36576">
+                    <a:solidFill>
+                      <a:srgbClr val="F5F5F5"/>
+                    </a:solidFill>
+                  </a:tcPr>
+                </a:tc>
+                <a:tc>
+                  <a:txBody>
+                    <a:bodyPr wrap="square"/>
+                    <a:lstStyle/>
+                    <a:p>
+                      <a:pPr algn="r"/>
+                      <a:r>
+                        <a:rPr sz="1300">
+                          <a:solidFill>
+                            <a:srgbClr val="1A1A1A"/>
+                          </a:solidFill>
+                          <a:latin typeface="Calibri"/>
+                        </a:rPr>
+                        <a:t>100%</a:t>
+                      </a:r>
+                    </a:p>
+                  </a:txBody>
+                  <a:tcPr marL="73152" marR="73152" marT="36576" marB="36576">
+                    <a:solidFill>
+                      <a:srgbClr val="F5F5F5"/>
+                    </a:solidFill>
+                  </a:tcPr>
+                </a:tc>
+                <a:tc>
+                  <a:txBody>
+                    <a:bodyPr wrap="square"/>
+                    <a:lstStyle/>
+                    <a:p>
+                      <a:pPr algn="r"/>
+                      <a:r>
+                        <a:rPr sz="1300">
+                          <a:solidFill>
+                            <a:srgbClr val="1A1A1A"/>
+                          </a:solidFill>
+                          <a:latin typeface="Calibri"/>
+                        </a:rPr>
+                        <a:t>—</a:t>
+                      </a:r>
+                    </a:p>
+                  </a:txBody>
+                  <a:tcPr marL="73152" marR="73152" marT="36576" marB="36576">
+                    <a:solidFill>
+                      <a:srgbClr val="F5F5F5"/>
+                    </a:solidFill>
+                  </a:tcPr>
+                </a:tc>
+              </a:tr>
+              <a:tr h="310896">
+                <a:tc>
+                  <a:txBody>
+                    <a:bodyPr wrap="square"/>
+                    <a:lstStyle/>
+                    <a:p>
+                      <a:pPr algn="l"/>
+                      <a:r>
+                        <a:rPr sz="1300">
+                          <a:solidFill>
+                            <a:srgbClr val="1A1A1A"/>
+                          </a:solidFill>
+                          <a:latin typeface="Calibri"/>
+                        </a:rPr>
+                        <a:t>DeepSeek V4 Pro</a:t>
+                      </a:r>
+                    </a:p>
+                  </a:txBody>
+                  <a:tcPr marL="73152" marR="73152" marT="36576" marB="36576">
+                    <a:solidFill>
+                      <a:srgbClr val="FFFFFF"/>
+                    </a:solidFill>
+                  </a:tcPr>
+                </a:tc>
+                <a:tc>
+                  <a:txBody>
+                    <a:bodyPr wrap="square"/>
+                    <a:lstStyle/>
+                    <a:p>
+                      <a:pPr algn="r"/>
+                      <a:r>
+                        <a:rPr sz="1300">
+                          <a:solidFill>
+                            <a:srgbClr val="1A1A1A"/>
+                          </a:solidFill>
+                          <a:latin typeface="Calibri"/>
+                        </a:rPr>
+                        <a:t>39%</a:t>
+                      </a:r>
+                    </a:p>
+                  </a:txBody>
+                  <a:tcPr marL="73152" marR="73152" marT="36576" marB="36576">
+                    <a:solidFill>
+                      <a:srgbClr val="FFFFFF"/>
+                    </a:solidFill>
+                  </a:tcPr>
+                </a:tc>
+                <a:tc>
+                  <a:txBody>
+                    <a:bodyPr wrap="square"/>
+                    <a:lstStyle/>
+                    <a:p>
+                      <a:pPr algn="r"/>
+                      <a:r>
+                        <a:rPr sz="1300">
+                          <a:solidFill>
+                            <a:srgbClr val="1A1A1A"/>
+                          </a:solidFill>
+                          <a:latin typeface="Calibri"/>
+                        </a:rPr>
+                        <a:t>84%</a:t>
+                      </a:r>
+                    </a:p>
+                  </a:txBody>
+                  <a:tcPr marL="73152" marR="73152" marT="36576" marB="36576">
+                    <a:solidFill>
+                      <a:srgbClr val="FFFFFF"/>
+                    </a:solidFill>
+                  </a:tcPr>
+                </a:tc>
+                <a:tc>
+                  <a:txBody>
+                    <a:bodyPr wrap="square"/>
+                    <a:lstStyle/>
+                    <a:p>
+                      <a:pPr algn="r"/>
+                      <a:r>
+                        <a:rPr sz="1300">
+                          <a:solidFill>
+                            <a:srgbClr val="1A1A1A"/>
+                          </a:solidFill>
+                          <a:latin typeface="Calibri"/>
+                        </a:rPr>
+                        <a:t>83%</a:t>
+                      </a:r>
+                    </a:p>
+                  </a:txBody>
+                  <a:tcPr marL="73152" marR="73152" marT="36576" marB="36576">
+                    <a:solidFill>
+                      <a:srgbClr val="FFFFFF"/>
+                    </a:solidFill>
+                  </a:tcPr>
+                </a:tc>
+              </a:tr>
+              <a:tr h="310896">
+                <a:tc>
+                  <a:txBody>
+                    <a:bodyPr wrap="square"/>
+                    <a:lstStyle/>
+                    <a:p>
+                      <a:pPr algn="l"/>
+                      <a:r>
+                        <a:rPr sz="1300">
+                          <a:solidFill>
+                            <a:srgbClr val="1A1A1A"/>
+                          </a:solidFill>
+                          <a:latin typeface="Calibri"/>
+                        </a:rPr>
+                        <a:t>Gemini 3.1 Pro Preview</a:t>
+                      </a:r>
+                    </a:p>
+                  </a:txBody>
+                  <a:tcPr marL="73152" marR="73152" marT="36576" marB="36576">
+                    <a:solidFill>
+                      <a:srgbClr val="F5F5F5"/>
+                    </a:solidFill>
+                  </a:tcPr>
+                </a:tc>
+                <a:tc>
+                  <a:txBody>
+                    <a:bodyPr wrap="square"/>
+                    <a:lstStyle/>
+                    <a:p>
+                      <a:pPr algn="r"/>
+                      <a:r>
+                        <a:rPr sz="1300">
+                          <a:solidFill>
+                            <a:srgbClr val="1A1A1A"/>
+                          </a:solidFill>
+                          <a:latin typeface="Calibri"/>
+                        </a:rPr>
+                        <a:t>24%</a:t>
+                      </a:r>
+                    </a:p>
+                  </a:txBody>
+                  <a:tcPr marL="73152" marR="73152" marT="36576" marB="36576">
+                    <a:solidFill>
+                      <a:srgbClr val="F5F5F5"/>
+                    </a:solidFill>
+                  </a:tcPr>
+                </a:tc>
+                <a:tc>
+                  <a:txBody>
+                    <a:bodyPr wrap="square"/>
+                    <a:lstStyle/>
+                    <a:p>
+                      <a:pPr algn="r"/>
+                      <a:r>
+                        <a:rPr sz="1300">
+                          <a:solidFill>
+                            <a:srgbClr val="1A1A1A"/>
+                          </a:solidFill>
+                          <a:latin typeface="Calibri"/>
+                        </a:rPr>
+                        <a:t>60%</a:t>
+                      </a:r>
+                    </a:p>
+                  </a:txBody>
+                  <a:tcPr marL="73152" marR="73152" marT="36576" marB="36576">
+                    <a:solidFill>
+                      <a:srgbClr val="F5F5F5"/>
+                    </a:solidFill>
+                  </a:tcPr>
+                </a:tc>
+                <a:tc>
+                  <a:txBody>
+                    <a:bodyPr wrap="square"/>
+                    <a:lstStyle/>
+                    <a:p>
+                      <a:pPr algn="r"/>
+                      <a:r>
+                        <a:rPr sz="1300">
+                          <a:solidFill>
+                            <a:srgbClr val="1A1A1A"/>
+                          </a:solidFill>
+                          <a:latin typeface="Calibri"/>
+                        </a:rPr>
+                        <a:t>44%</a:t>
+                      </a:r>
+                    </a:p>
+                  </a:txBody>
+                  <a:tcPr marL="73152" marR="73152" marT="36576" marB="36576">
+                    <a:solidFill>
+                      <a:srgbClr val="F5F5F5"/>
+                    </a:solidFill>
+                  </a:tcPr>
+                </a:tc>
+              </a:tr>
+              <a:tr h="310896">
+                <a:tc>
+                  <a:txBody>
+                    <a:bodyPr wrap="square"/>
+                    <a:lstStyle/>
+                    <a:p>
+                      <a:pPr algn="l"/>
+                      <a:r>
+                        <a:rPr sz="1300">
+                          <a:solidFill>
+                            <a:srgbClr val="1A1A1A"/>
+                          </a:solidFill>
+                          <a:latin typeface="Calibri"/>
+                        </a:rPr>
+                        <a:t>Gemini 2.5 Pro</a:t>
+                      </a:r>
+                    </a:p>
+                  </a:txBody>
+                  <a:tcPr marL="73152" marR="73152" marT="36576" marB="36576">
+                    <a:solidFill>
+                      <a:srgbClr val="FFFFFF"/>
+                    </a:solidFill>
+                  </a:tcPr>
+                </a:tc>
+                <a:tc>
+                  <a:txBody>
+                    <a:bodyPr wrap="square"/>
+                    <a:lstStyle/>
+                    <a:p>
+                      <a:pPr algn="r"/>
+                      <a:r>
+                        <a:rPr sz="1300">
+                          <a:solidFill>
+                            <a:srgbClr val="1A1A1A"/>
+                          </a:solidFill>
+                          <a:latin typeface="Calibri"/>
+                        </a:rPr>
+                        <a:t>17%</a:t>
+                      </a:r>
+                    </a:p>
+                  </a:txBody>
+                  <a:tcPr marL="73152" marR="73152" marT="36576" marB="36576">
+                    <a:solidFill>
+                      <a:srgbClr val="FFFFFF"/>
+                    </a:solidFill>
+                  </a:tcPr>
+                </a:tc>
+                <a:tc>
+                  <a:txBody>
+                    <a:bodyPr wrap="square"/>
+                    <a:lstStyle/>
+                    <a:p>
+                      <a:pPr algn="r"/>
+                      <a:r>
+                        <a:rPr sz="1300">
+                          <a:solidFill>
+                            <a:srgbClr val="1A1A1A"/>
+                          </a:solidFill>
+                          <a:latin typeface="Calibri"/>
+                        </a:rPr>
+                        <a:t>86%</a:t>
+                      </a:r>
+                    </a:p>
+                  </a:txBody>
+                  <a:tcPr marL="73152" marR="73152" marT="36576" marB="36576">
+                    <a:solidFill>
+                      <a:srgbClr val="FFFFFF"/>
+                    </a:solidFill>
+                  </a:tcPr>
+                </a:tc>
+                <a:tc>
+                  <a:txBody>
+                    <a:bodyPr wrap="square"/>
+                    <a:lstStyle/>
+                    <a:p>
+                      <a:pPr algn="r"/>
+                      <a:r>
+                        <a:rPr sz="1300">
+                          <a:solidFill>
+                            <a:srgbClr val="1A1A1A"/>
+                          </a:solidFill>
+                          <a:latin typeface="Calibri"/>
+                        </a:rPr>
+                        <a:t>6%</a:t>
+                      </a:r>
+                    </a:p>
+                  </a:txBody>
+                  <a:tcPr marL="73152" marR="73152" marT="36576" marB="36576">
+                    <a:solidFill>
+                      <a:srgbClr val="FFFFFF"/>
+                    </a:solidFill>
+                  </a:tcPr>
+                </a:tc>
+              </a:tr>
+            </a:tbl>
+          </a:graphicData>
+        </a:graphic>
+      </p:graphicFrame>
+      <p:sp>
+        <p:nvSpPr>
+          <p:cNvPr id="4" name="TextBox 3"/>
           <p:cNvSpPr txBox="1"/>
           <p:nvPr/>
         </p:nvSpPr>
         <p:spPr>
           <a:xfrm>
-            <a:off x="640080" y="1280160"/>
-            <a:ext cx="11430000" cy="4572000"/>
+            <a:off x="457200" y="5669280"/>
+            <a:ext cx="10972800" cy="914400"/>
           </a:xfrm>
           <a:prstGeom prst="rect">
             <a:avLst/>
@@ -12010,159 +13127,27 @@
           <a:noFill/>
         </p:spPr>
         <p:txBody>
-          <a:bodyPr wrap="square">
+          <a:bodyPr wrap="square" anchor="t">
             <a:spAutoFit/>
           </a:bodyPr>
           <a:lstStyle/>
           <a:p>
-            <a:pPr>
-              <a:lnSpc>
-                <a:spcPct val="130000"/>
-              </a:lnSpc>
-            </a:pPr>
-            <a:r>
-              <a:rPr sz="1600" b="1">
+            <a:pPr algn="l"/>
+            <a:r>
+              <a:rPr sz="1300" b="0">
                 <a:solidFill>
                   <a:srgbClr val="1A1A1A"/>
                 </a:solidFill>
                 <a:latin typeface="Calibri"/>
               </a:rPr>
-              <a:t>• Thakur et al. 2025: GPT-4o single judge, κ = 0.60 on 537-pair "support evaluation" subset</a:t>
-            </a:r>
-          </a:p>
-          <a:p>
-            <a:pPr>
-              <a:lnSpc>
-                <a:spcPct val="130000"/>
-              </a:lnSpc>
-            </a:pPr>
-            <a:r>
-              <a:rPr sz="1600" b="1">
-                <a:solidFill>
-                  <a:srgbClr val="1A1A1A"/>
-                </a:solidFill>
-                <a:latin typeface="Calibri"/>
-              </a:rPr>
-              <a:t>• Our GPT-4o on our 537-pair stratified-balanced sample: κ = 0.41 (gap of 0.19)</a:t>
-            </a:r>
-          </a:p>
-          <a:p>
-            <a:pPr>
-              <a:lnSpc>
-                <a:spcPct val="130000"/>
-              </a:lnSpc>
-            </a:pPr>
-            <a:r>
-              <a:rPr sz="1600" b="0">
-                <a:solidFill>
-                  <a:srgbClr val="1A1A1A"/>
-                </a:solidFill>
-                <a:latin typeface="Calibri"/>
-              </a:rPr>
-              <a:t>• Our 9-judge ensemble: κ = 0.49 — partially closes the gap (+0.08 over our GPT-4o)</a:t>
-            </a:r>
-          </a:p>
-          <a:p>
-            <a:pPr>
-              <a:lnSpc>
-                <a:spcPct val="130000"/>
-              </a:lnSpc>
-            </a:pPr>
-            <a:r>
-              <a:rPr sz="1600" b="1">
-                <a:solidFill>
-                  <a:srgbClr val="1A1A1A"/>
-                </a:solidFill>
-                <a:latin typeface="Calibri"/>
-              </a:rPr>
-              <a:t>• Likely explanations for the gap (in decreasing impact order):</a:t>
-            </a:r>
-          </a:p>
-          <a:p>
-            <a:pPr>
-              <a:lnSpc>
-                <a:spcPct val="130000"/>
-              </a:lnSpc>
-            </a:pPr>
-            <a:r>
-              <a:rPr sz="1600" b="0">
-                <a:solidFill>
-                  <a:srgbClr val="1A1A1A"/>
-                </a:solidFill>
-                <a:latin typeface="Calibri"/>
-              </a:rPr>
-              <a:t>•     Sample selection — ours stratified-balanced (uniform), theirs natural-distribution-proportional</a:t>
-            </a:r>
-          </a:p>
-          <a:p>
-            <a:pPr>
-              <a:lnSpc>
-                <a:spcPct val="130000"/>
-              </a:lnSpc>
-            </a:pPr>
-            <a:r>
-              <a:rPr sz="1600" b="0">
-                <a:solidFill>
-                  <a:srgbClr val="1A1A1A"/>
-                </a:solidFill>
-                <a:latin typeface="Calibri"/>
-              </a:rPr>
-              <a:t>•     Prompt template — exact Thakur prompt not specified in their paper</a:t>
-            </a:r>
-          </a:p>
-          <a:p>
-            <a:pPr>
-              <a:lnSpc>
-                <a:spcPct val="130000"/>
-              </a:lnSpc>
-            </a:pPr>
-            <a:r>
-              <a:rPr sz="1600" b="0">
-                <a:solidFill>
-                  <a:srgbClr val="1A1A1A"/>
-                </a:solidFill>
-                <a:latin typeface="Calibri"/>
-              </a:rPr>
-              <a:t>•     Qrels version — possible UMBRELA-augmented vs official NIST</a:t>
-            </a:r>
-          </a:p>
-          <a:p>
-            <a:pPr>
-              <a:lnSpc>
-                <a:spcPct val="130000"/>
-              </a:lnSpc>
-            </a:pPr>
-            <a:r>
-              <a:rPr sz="1600" b="0">
-                <a:solidFill>
-                  <a:srgbClr val="1A1A1A"/>
-                </a:solidFill>
-                <a:latin typeface="Calibri"/>
-              </a:rPr>
-              <a:t>•     Judge model version — we pin gpt-4o-2024-08-06; theirs unspecified</a:t>
-            </a:r>
-          </a:p>
-          <a:p>
-            <a:pPr>
-              <a:lnSpc>
-                <a:spcPct val="130000"/>
-              </a:lnSpc>
-            </a:pPr>
-            <a:r>
-              <a:rPr sz="1600" b="0">
-                <a:solidFill>
-                  <a:srgbClr val="1A1A1A"/>
-                </a:solidFill>
-                <a:latin typeface="Calibri"/>
-              </a:rPr>
-              <a:t>• Direct apples-to-apples replication awaits receipt of their curated 537-pair subset</a:t>
-            </a:r>
-          </a:p>
-        </p:txBody>
-      </p:sp>
-      <p:sp>
-        <p:nvSpPr>
-          <p:cNvPr id="4" name="TextBox 3"/>
+              <a:t>ALWAYS-WORKS 6-judge subset (≥95% on TREC RAG + BEIR scifact): Anthropic + OpenAI + Qwen + Gemma. The 2 cheapest open-weight judges make this subset. Gemini fails on web/biomedical content more than on scientific abstracts — reliability is content-domain dependent.</a:t>
+            </a:r>
+          </a:p>
+        </p:txBody>
+      </p:sp>
+      <p:sp>
+        <p:nvSpPr>
+          <p:cNvPr id="5" name="TextBox 4"/>
           <p:cNvSpPr txBox="1"/>
           <p:nvPr/>
         </p:nvSpPr>
@@ -12197,7 +13182,7 @@
       </p:sp>
       <p:sp>
         <p:nvSpPr>
-          <p:cNvPr id="5" name="TextBox 4"/>
+          <p:cNvPr id="6" name="TextBox 5"/>
           <p:cNvSpPr txBox="1"/>
           <p:nvPr/>
         </p:nvSpPr>
@@ -12225,7 +13210,7 @@
                 </a:solidFill>
                 <a:latin typeface="Calibri"/>
               </a:rPr>
-              <a:t>27/32</a:t>
+              <a:t>27/33</a:t>
             </a:r>
           </a:p>
         </p:txBody>
@@ -12278,7 +13263,7 @@
                 </a:solidFill>
                 <a:latin typeface="Calibri"/>
               </a:rPr>
-              <a:t>Limitations</a:t>
+              <a:t>Comparison to Thakur 2025 baseline</a:t>
             </a:r>
           </a:p>
         </p:txBody>
@@ -12292,7 +13277,7 @@
         <p:spPr>
           <a:xfrm>
             <a:off x="640080" y="1280160"/>
-            <a:ext cx="11430000" cy="4937760"/>
+            <a:ext cx="11430000" cy="4572000"/>
           </a:xfrm>
           <a:prstGeom prst="rect">
             <a:avLst/>
@@ -12307,39 +13292,39 @@
           <a:p>
             <a:pPr>
               <a:lnSpc>
-                <a:spcPct val="125000"/>
+                <a:spcPct val="130000"/>
               </a:lnSpc>
             </a:pPr>
             <a:r>
-              <a:rPr sz="1600" b="0">
+              <a:rPr sz="1600" b="1">
                 <a:solidFill>
                   <a:srgbClr val="1A1A1A"/>
                 </a:solidFill>
                 <a:latin typeface="Calibri"/>
               </a:rPr>
-              <a:t>• Single internal corpus (ISU DSpace) — open-weight κ ceiling most likely to drift across domains</a:t>
+              <a:t>• Thakur et al. 2025: GPT-4o single judge, κ = 0.60 on 537-pair "support evaluation" subset</a:t>
             </a:r>
           </a:p>
           <a:p>
             <a:pPr>
               <a:lnSpc>
-                <a:spcPct val="125000"/>
+                <a:spcPct val="130000"/>
               </a:lnSpc>
             </a:pPr>
             <a:r>
-              <a:rPr sz="1600" b="0">
+              <a:rPr sz="1600" b="1">
                 <a:solidFill>
                   <a:srgbClr val="1A1A1A"/>
                 </a:solidFill>
                 <a:latin typeface="Calibri"/>
               </a:rPr>
-              <a:t>• Single internal query set (REFINE 57 queries) — κ structure could depend on intent distribution</a:t>
+              <a:t>• Our GPT-4o on our 537-pair stratified-balanced sample: κ = 0.41 (gap of 0.19)</a:t>
             </a:r>
           </a:p>
           <a:p>
             <a:pPr>
               <a:lnSpc>
-                <a:spcPct val="125000"/>
+                <a:spcPct val="130000"/>
               </a:lnSpc>
             </a:pPr>
             <a:r>
@@ -12349,13 +13334,13 @@
                 </a:solidFill>
                 <a:latin typeface="Calibri"/>
               </a:rPr>
-              <a:t>• Stratified sample mismatch with Thakur 2025 — ours balanced, theirs natural-proportional</a:t>
+              <a:t>• Our 9-judge ensemble: κ = 0.49 — partially closes the gap (+0.08 over our GPT-4o)</a:t>
             </a:r>
           </a:p>
           <a:p>
             <a:pPr>
               <a:lnSpc>
-                <a:spcPct val="125000"/>
+                <a:spcPct val="130000"/>
               </a:lnSpc>
             </a:pPr>
             <a:r>
@@ -12365,13 +13350,13 @@
                 </a:solidFill>
                 <a:latin typeface="Calibri"/>
               </a:rPr>
-              <a:t>• Gemini coverage failures (17-24% on TREC RAG 2024) — selection bias on the small valid subset</a:t>
+              <a:t>• Likely explanations for the gap (in decreasing impact order):</a:t>
             </a:r>
           </a:p>
           <a:p>
             <a:pPr>
               <a:lnSpc>
-                <a:spcPct val="125000"/>
+                <a:spcPct val="130000"/>
               </a:lnSpc>
             </a:pPr>
             <a:r>
@@ -12381,13 +13366,13 @@
                 </a:solidFill>
                 <a:latin typeface="Calibri"/>
               </a:rPr>
-              <a:t>• DSV4 Flash dropped — OpenRouter free-tier 429 throttling; we have 1 DeepSeek judge, no within-DS pair</a:t>
+              <a:t>•     Sample selection — ours stratified-balanced (uniform), theirs natural-distribution-proportional</a:t>
             </a:r>
           </a:p>
           <a:p>
             <a:pPr>
               <a:lnSpc>
-                <a:spcPct val="125000"/>
+                <a:spcPct val="130000"/>
               </a:lnSpc>
             </a:pPr>
             <a:r>
@@ -12397,13 +13382,13 @@
                 </a:solidFill>
                 <a:latin typeface="Calibri"/>
               </a:rPr>
-              <a:t>• Missing-data accounting — None=0 in aggregates; valid-only means re-cluster Gemini judges as strict-mid</a:t>
+              <a:t>•     Prompt template — exact Thakur prompt not specified in their paper</a:t>
             </a:r>
           </a:p>
           <a:p>
             <a:pPr>
               <a:lnSpc>
-                <a:spcPct val="125000"/>
+                <a:spcPct val="130000"/>
               </a:lnSpc>
             </a:pPr>
             <a:r>
@@ -12413,23 +13398,39 @@
                 </a:solidFill>
                 <a:latin typeface="Calibri"/>
               </a:rPr>
-              <a:t>• Mediation analysis assumes linear additivity — non-linear interactions (provider × reasoning) untested</a:t>
+              <a:t>•     Qrels version — possible UMBRELA-augmented vs official NIST</a:t>
             </a:r>
           </a:p>
           <a:p>
             <a:pPr>
               <a:lnSpc>
-                <a:spcPct val="125000"/>
+                <a:spcPct val="130000"/>
               </a:lnSpc>
             </a:pPr>
             <a:r>
-              <a:rPr sz="1600" b="1">
+              <a:rPr sz="1600" b="0">
                 <a:solidFill>
                   <a:srgbClr val="1A1A1A"/>
                 </a:solidFill>
                 <a:latin typeface="Calibri"/>
               </a:rPr>
-              <a:t>• No within-corpus human-rater study — §7 NIST validation substitutes; reviewers preferring institution-specific human anchor will not find one</a:t>
+              <a:t>•     Judge model version — we pin gpt-4o-2024-08-06; theirs unspecified</a:t>
+            </a:r>
+          </a:p>
+          <a:p>
+            <a:pPr>
+              <a:lnSpc>
+                <a:spcPct val="130000"/>
+              </a:lnSpc>
+            </a:pPr>
+            <a:r>
+              <a:rPr sz="1600" b="0">
+                <a:solidFill>
+                  <a:srgbClr val="1A1A1A"/>
+                </a:solidFill>
+                <a:latin typeface="Calibri"/>
+              </a:rPr>
+              <a:t>• Direct apples-to-apples replication awaits receipt of their curated 537-pair subset</a:t>
             </a:r>
           </a:p>
         </p:txBody>
@@ -12499,7 +13500,7 @@
                 </a:solidFill>
                 <a:latin typeface="Calibri"/>
               </a:rPr>
-              <a:t>28/32</a:t>
+              <a:t>28/33</a:t>
             </a:r>
           </a:p>
         </p:txBody>
@@ -12552,7 +13553,7 @@
                 </a:solidFill>
                 <a:latin typeface="Calibri"/>
               </a:rPr>
-              <a:t>Reproducibility — single-command replication</a:t>
+              <a:t>Limitations</a:t>
             </a:r>
           </a:p>
         </p:txBody>
@@ -12566,7 +13567,7 @@
         <p:spPr>
           <a:xfrm>
             <a:off x="640080" y="1280160"/>
-            <a:ext cx="11430000" cy="457200"/>
+            <a:ext cx="11430000" cy="4937760"/>
           </a:xfrm>
           <a:prstGeom prst="rect">
             <a:avLst/>
@@ -12574,20 +13575,136 @@
           <a:noFill/>
         </p:spPr>
         <p:txBody>
-          <a:bodyPr wrap="square" anchor="t">
+          <a:bodyPr wrap="square">
             <a:spAutoFit/>
           </a:bodyPr>
           <a:lstStyle/>
           <a:p>
-            <a:pPr algn="l"/>
-            <a:r>
-              <a:rPr sz="1800" b="1">
-                <a:solidFill>
-                  <a:srgbClr val="0E4A86"/>
-                </a:solidFill>
-                <a:latin typeface="Calibri"/>
-              </a:rPr>
-              <a:t>Within-corpus replication (~$18, ~5.5 h):</a:t>
+            <a:pPr>
+              <a:lnSpc>
+                <a:spcPct val="125000"/>
+              </a:lnSpc>
+            </a:pPr>
+            <a:r>
+              <a:rPr sz="1600" b="0">
+                <a:solidFill>
+                  <a:srgbClr val="1A1A1A"/>
+                </a:solidFill>
+                <a:latin typeface="Calibri"/>
+              </a:rPr>
+              <a:t>• Single internal corpus (ISU DSpace) — open-weight κ ceiling most likely to drift across domains</a:t>
+            </a:r>
+          </a:p>
+          <a:p>
+            <a:pPr>
+              <a:lnSpc>
+                <a:spcPct val="125000"/>
+              </a:lnSpc>
+            </a:pPr>
+            <a:r>
+              <a:rPr sz="1600" b="0">
+                <a:solidFill>
+                  <a:srgbClr val="1A1A1A"/>
+                </a:solidFill>
+                <a:latin typeface="Calibri"/>
+              </a:rPr>
+              <a:t>• Single internal query set (REFINE 57 queries) — κ structure could depend on intent distribution</a:t>
+            </a:r>
+          </a:p>
+          <a:p>
+            <a:pPr>
+              <a:lnSpc>
+                <a:spcPct val="125000"/>
+              </a:lnSpc>
+            </a:pPr>
+            <a:r>
+              <a:rPr sz="1600" b="0">
+                <a:solidFill>
+                  <a:srgbClr val="1A1A1A"/>
+                </a:solidFill>
+                <a:latin typeface="Calibri"/>
+              </a:rPr>
+              <a:t>• Stratified sample mismatch with Thakur 2025 — ours balanced, theirs natural-proportional</a:t>
+            </a:r>
+          </a:p>
+          <a:p>
+            <a:pPr>
+              <a:lnSpc>
+                <a:spcPct val="125000"/>
+              </a:lnSpc>
+            </a:pPr>
+            <a:r>
+              <a:rPr sz="1600" b="1">
+                <a:solidFill>
+                  <a:srgbClr val="1A1A1A"/>
+                </a:solidFill>
+                <a:latin typeface="Calibri"/>
+              </a:rPr>
+              <a:t>• Gemini coverage failures (17-24% on TREC RAG 2024) — selection bias on the small valid subset</a:t>
+            </a:r>
+          </a:p>
+          <a:p>
+            <a:pPr>
+              <a:lnSpc>
+                <a:spcPct val="125000"/>
+              </a:lnSpc>
+            </a:pPr>
+            <a:r>
+              <a:rPr sz="1600" b="0">
+                <a:solidFill>
+                  <a:srgbClr val="1A1A1A"/>
+                </a:solidFill>
+                <a:latin typeface="Calibri"/>
+              </a:rPr>
+              <a:t>• DSV4 Flash dropped — OpenRouter free-tier 429 throttling; we have 1 DeepSeek judge, no within-DS pair</a:t>
+            </a:r>
+          </a:p>
+          <a:p>
+            <a:pPr>
+              <a:lnSpc>
+                <a:spcPct val="125000"/>
+              </a:lnSpc>
+            </a:pPr>
+            <a:r>
+              <a:rPr sz="1600" b="0">
+                <a:solidFill>
+                  <a:srgbClr val="1A1A1A"/>
+                </a:solidFill>
+                <a:latin typeface="Calibri"/>
+              </a:rPr>
+              <a:t>• Missing-data accounting — None=0 in aggregates; valid-only means re-cluster Gemini judges as strict-mid</a:t>
+            </a:r>
+          </a:p>
+          <a:p>
+            <a:pPr>
+              <a:lnSpc>
+                <a:spcPct val="125000"/>
+              </a:lnSpc>
+            </a:pPr>
+            <a:r>
+              <a:rPr sz="1600" b="0">
+                <a:solidFill>
+                  <a:srgbClr val="1A1A1A"/>
+                </a:solidFill>
+                <a:latin typeface="Calibri"/>
+              </a:rPr>
+              <a:t>• Mediation analysis assumes linear additivity — non-linear interactions (provider × reasoning) untested</a:t>
+            </a:r>
+          </a:p>
+          <a:p>
+            <a:pPr>
+              <a:lnSpc>
+                <a:spcPct val="125000"/>
+              </a:lnSpc>
+            </a:pPr>
+            <a:r>
+              <a:rPr sz="1600" b="1">
+                <a:solidFill>
+                  <a:srgbClr val="1A1A1A"/>
+                </a:solidFill>
+                <a:latin typeface="Calibri"/>
+              </a:rPr>
+              <a:t>• No within-corpus human-rater study — §7 NIST validation substitutes; reviewers preferring institution-specific human anchor will not find one</a:t>
             </a:r>
           </a:p>
         </p:txBody>
@@ -12595,251 +13712,6 @@
       <p:sp>
         <p:nvSpPr>
           <p:cNvPr id="4" name="TextBox 3"/>
-          <p:cNvSpPr txBox="1"/>
-          <p:nvPr/>
-        </p:nvSpPr>
-        <p:spPr>
-          <a:xfrm>
-            <a:off x="640080" y="1783080"/>
-            <a:ext cx="11430000" cy="457200"/>
-          </a:xfrm>
-          <a:prstGeom prst="rect">
-            <a:avLst/>
-          </a:prstGeom>
-          <a:noFill/>
-        </p:spPr>
-        <p:txBody>
-          <a:bodyPr wrap="square" anchor="t">
-            <a:spAutoFit/>
-          </a:bodyPr>
-          <a:lstStyle/>
-          <a:p>
-            <a:pPr algn="l"/>
-            <a:r>
-              <a:rPr sz="1500" b="0">
-                <a:solidFill>
-                  <a:srgbClr val="1A1A1A"/>
-                </a:solidFill>
-                <a:latin typeface="Consolas"/>
-              </a:rPr>
-              <a:t>py eval_llm_judge.py --collection &lt;yours&gt; --judge-preset p4-frontier</a:t>
-            </a:r>
-          </a:p>
-        </p:txBody>
-      </p:sp>
-      <p:sp>
-        <p:nvSpPr>
-          <p:cNvPr id="5" name="TextBox 4"/>
-          <p:cNvSpPr txBox="1"/>
-          <p:nvPr/>
-        </p:nvSpPr>
-        <p:spPr>
-          <a:xfrm>
-            <a:off x="640080" y="2194560"/>
-            <a:ext cx="11430000" cy="457200"/>
-          </a:xfrm>
-          <a:prstGeom prst="rect">
-            <a:avLst/>
-          </a:prstGeom>
-          <a:noFill/>
-        </p:spPr>
-        <p:txBody>
-          <a:bodyPr wrap="square" anchor="t">
-            <a:spAutoFit/>
-          </a:bodyPr>
-          <a:lstStyle/>
-          <a:p>
-            <a:pPr algn="l"/>
-            <a:r>
-              <a:rPr sz="1500" b="0">
-                <a:solidFill>
-                  <a:srgbClr val="1A1A1A"/>
-                </a:solidFill>
-                <a:latin typeface="Consolas"/>
-              </a:rPr>
-              <a:t>py eval_llm_judge.py --collection &lt;yours&gt; --judge-preset p4-supplement-openweight</a:t>
-            </a:r>
-          </a:p>
-        </p:txBody>
-      </p:sp>
-      <p:sp>
-        <p:nvSpPr>
-          <p:cNvPr id="6" name="TextBox 5"/>
-          <p:cNvSpPr txBox="1"/>
-          <p:nvPr/>
-        </p:nvSpPr>
-        <p:spPr>
-          <a:xfrm>
-            <a:off x="640080" y="2834640"/>
-            <a:ext cx="11430000" cy="457200"/>
-          </a:xfrm>
-          <a:prstGeom prst="rect">
-            <a:avLst/>
-          </a:prstGeom>
-          <a:noFill/>
-        </p:spPr>
-        <p:txBody>
-          <a:bodyPr wrap="square" anchor="t">
-            <a:spAutoFit/>
-          </a:bodyPr>
-          <a:lstStyle/>
-          <a:p>
-            <a:pPr algn="l"/>
-            <a:r>
-              <a:rPr sz="1800" b="1">
-                <a:solidFill>
-                  <a:srgbClr val="0E4A86"/>
-                </a:solidFill>
-                <a:latin typeface="Calibri"/>
-              </a:rPr>
-              <a:t>External-validation replication (~$35, ~7.5 h):</a:t>
-            </a:r>
-          </a:p>
-        </p:txBody>
-      </p:sp>
-      <p:sp>
-        <p:nvSpPr>
-          <p:cNvPr id="7" name="TextBox 6"/>
-          <p:cNvSpPr txBox="1"/>
-          <p:nvPr/>
-        </p:nvSpPr>
-        <p:spPr>
-          <a:xfrm>
-            <a:off x="640080" y="3337560"/>
-            <a:ext cx="11430000" cy="457200"/>
-          </a:xfrm>
-          <a:prstGeom prst="rect">
-            <a:avLst/>
-          </a:prstGeom>
-          <a:noFill/>
-        </p:spPr>
-        <p:txBody>
-          <a:bodyPr wrap="square" anchor="t">
-            <a:spAutoFit/>
-          </a:bodyPr>
-          <a:lstStyle/>
-          <a:p>
-            <a:pPr algn="l"/>
-            <a:r>
-              <a:rPr sz="1500" b="0">
-                <a:solidFill>
-                  <a:srgbClr val="1A1A1A"/>
-                </a:solidFill>
-                <a:latin typeface="Consolas"/>
-              </a:rPr>
-              <a:t>py validate_against_trec.py --corpus trec-rag-2024 --judge-preset p4-frontier --max-pairs 537</a:t>
-            </a:r>
-          </a:p>
-        </p:txBody>
-      </p:sp>
-      <p:sp>
-        <p:nvSpPr>
-          <p:cNvPr id="8" name="TextBox 7"/>
-          <p:cNvSpPr txBox="1"/>
-          <p:nvPr/>
-        </p:nvSpPr>
-        <p:spPr>
-          <a:xfrm>
-            <a:off x="640080" y="3749039"/>
-            <a:ext cx="11430000" cy="457200"/>
-          </a:xfrm>
-          <a:prstGeom prst="rect">
-            <a:avLst/>
-          </a:prstGeom>
-          <a:noFill/>
-        </p:spPr>
-        <p:txBody>
-          <a:bodyPr wrap="square" anchor="t">
-            <a:spAutoFit/>
-          </a:bodyPr>
-          <a:lstStyle/>
-          <a:p>
-            <a:pPr algn="l"/>
-            <a:r>
-              <a:rPr sz="1500" b="0">
-                <a:solidFill>
-                  <a:srgbClr val="1A1A1A"/>
-                </a:solidFill>
-                <a:latin typeface="Consolas"/>
-              </a:rPr>
-              <a:t>py validate_against_trec.py --corpus trec-rag-2024 --judge-preset p4-supplement-openweight --max-pairs 537</a:t>
-            </a:r>
-          </a:p>
-        </p:txBody>
-      </p:sp>
-      <p:sp>
-        <p:nvSpPr>
-          <p:cNvPr id="9" name="TextBox 8"/>
-          <p:cNvSpPr txBox="1"/>
-          <p:nvPr/>
-        </p:nvSpPr>
-        <p:spPr>
-          <a:xfrm>
-            <a:off x="640080" y="4160520"/>
-            <a:ext cx="11430000" cy="457200"/>
-          </a:xfrm>
-          <a:prstGeom prst="rect">
-            <a:avLst/>
-          </a:prstGeom>
-          <a:noFill/>
-        </p:spPr>
-        <p:txBody>
-          <a:bodyPr wrap="square" anchor="t">
-            <a:spAutoFit/>
-          </a:bodyPr>
-          <a:lstStyle/>
-          <a:p>
-            <a:pPr algn="l"/>
-            <a:r>
-              <a:rPr sz="1500" b="0">
-                <a:solidFill>
-                  <a:srgbClr val="1A1A1A"/>
-                </a:solidFill>
-                <a:latin typeface="Consolas"/>
-              </a:rPr>
-              <a:t>py validate_against_trec.py --analyze trec-rag-2024</a:t>
-            </a:r>
-          </a:p>
-        </p:txBody>
-      </p:sp>
-      <p:sp>
-        <p:nvSpPr>
-          <p:cNvPr id="10" name="TextBox 9"/>
-          <p:cNvSpPr txBox="1"/>
-          <p:nvPr/>
-        </p:nvSpPr>
-        <p:spPr>
-          <a:xfrm>
-            <a:off x="640080" y="4937760"/>
-            <a:ext cx="11430000" cy="1371600"/>
-          </a:xfrm>
-          <a:prstGeom prst="rect">
-            <a:avLst/>
-          </a:prstGeom>
-          <a:noFill/>
-        </p:spPr>
-        <p:txBody>
-          <a:bodyPr wrap="square" anchor="t">
-            <a:spAutoFit/>
-          </a:bodyPr>
-          <a:lstStyle/>
-          <a:p>
-            <a:pPr algn="l"/>
-            <a:r>
-              <a:rPr sz="1300" b="0">
-                <a:solidFill>
-                  <a:srgbClr val="707070"/>
-                </a:solidFill>
-                <a:latin typeface="Calibri"/>
-              </a:rPr>
-              <a:t>Model versions pinned 2026-04-25: claude-opus-4-7, claude-sonnet-4-6, gpt-5.5, gpt-4o-2024-08-06, gemini-3.1-pro-preview, gemini-2.5-pro-2025-06-17, deepseek-v4-pro, qwen3.6-plus, gemma-4-26b-a4b-it. Target SIGIR Artifact Badging (Functional / Reusable).</a:t>
-            </a:r>
-          </a:p>
-        </p:txBody>
-      </p:sp>
-      <p:sp>
-        <p:nvSpPr>
-          <p:cNvPr id="11" name="TextBox 10"/>
           <p:cNvSpPr txBox="1"/>
           <p:nvPr/>
         </p:nvSpPr>
@@ -12874,7 +13746,7 @@
       </p:sp>
       <p:sp>
         <p:nvSpPr>
-          <p:cNvPr id="12" name="TextBox 11"/>
+          <p:cNvPr id="5" name="TextBox 4"/>
           <p:cNvSpPr txBox="1"/>
           <p:nvPr/>
         </p:nvSpPr>
@@ -12902,7 +13774,7 @@
                 </a:solidFill>
                 <a:latin typeface="Calibri"/>
               </a:rPr>
-              <a:t>29/32</a:t>
+              <a:t>29/33</a:t>
             </a:r>
           </a:p>
         </p:txBody>
@@ -13163,7 +14035,7 @@
                 </a:solidFill>
                 <a:latin typeface="Calibri"/>
               </a:rPr>
-              <a:t>3/32</a:t>
+              <a:t>3/33</a:t>
             </a:r>
           </a:p>
         </p:txBody>
@@ -13216,7 +14088,7 @@
                 </a:solidFill>
                 <a:latin typeface="Calibri"/>
               </a:rPr>
-              <a:t>Open questions for follow-up</a:t>
+              <a:t>Reproducibility — single-command replication</a:t>
             </a:r>
           </a:p>
         </p:txBody>
@@ -13230,7 +14102,7 @@
         <p:spPr>
           <a:xfrm>
             <a:off x="640080" y="1280160"/>
-            <a:ext cx="11430000" cy="4572000"/>
+            <a:ext cx="11430000" cy="457200"/>
           </a:xfrm>
           <a:prstGeom prst="rect">
             <a:avLst/>
@@ -13238,111 +14110,272 @@
           <a:noFill/>
         </p:spPr>
         <p:txBody>
-          <a:bodyPr wrap="square">
+          <a:bodyPr wrap="square" anchor="t">
             <a:spAutoFit/>
           </a:bodyPr>
           <a:lstStyle/>
           <a:p>
-            <a:pPr>
-              <a:lnSpc>
-                <a:spcPct val="130000"/>
-              </a:lnSpc>
-            </a:pPr>
-            <a:r>
-              <a:rPr sz="1700" b="1">
+            <a:pPr algn="l"/>
+            <a:r>
+              <a:rPr sz="1800" b="1">
+                <a:solidFill>
+                  <a:srgbClr val="0E4A86"/>
+                </a:solidFill>
+                <a:latin typeface="Calibri"/>
+              </a:rPr>
+              <a:t>Within-corpus replication (~$18, ~5.5 h):</a:t>
+            </a:r>
+          </a:p>
+        </p:txBody>
+      </p:sp>
+      <p:sp>
+        <p:nvSpPr>
+          <p:cNvPr id="4" name="TextBox 3"/>
+          <p:cNvSpPr txBox="1"/>
+          <p:nvPr/>
+        </p:nvSpPr>
+        <p:spPr>
+          <a:xfrm>
+            <a:off x="640080" y="1783080"/>
+            <a:ext cx="11430000" cy="457200"/>
+          </a:xfrm>
+          <a:prstGeom prst="rect">
+            <a:avLst/>
+          </a:prstGeom>
+          <a:noFill/>
+        </p:spPr>
+        <p:txBody>
+          <a:bodyPr wrap="square" anchor="t">
+            <a:spAutoFit/>
+          </a:bodyPr>
+          <a:lstStyle/>
+          <a:p>
+            <a:pPr algn="l"/>
+            <a:r>
+              <a:rPr sz="1500" b="0">
                 <a:solidFill>
                   <a:srgbClr val="1A1A1A"/>
                 </a:solidFill>
-                <a:latin typeface="Calibri"/>
-              </a:rPr>
-              <a:t>• (1) Cross-organization Qwen ↔ Gemma 4 convergence (κ=0.80) lacks complete mechanistic explanation — shared OSS research community? distillation lineage? compute regime? bounded-output prior?</a:t>
-            </a:r>
-          </a:p>
-          <a:p>
-            <a:pPr>
-              <a:lnSpc>
-                <a:spcPct val="130000"/>
-              </a:lnSpc>
-            </a:pPr>
-            <a:r>
-              <a:rPr sz="1700" b="0">
+                <a:latin typeface="Consolas"/>
+              </a:rPr>
+              <a:t>py eval_llm_judge.py --collection &lt;yours&gt; --judge-preset p4-frontier</a:t>
+            </a:r>
+          </a:p>
+        </p:txBody>
+      </p:sp>
+      <p:sp>
+        <p:nvSpPr>
+          <p:cNvPr id="5" name="TextBox 4"/>
+          <p:cNvSpPr txBox="1"/>
+          <p:nvPr/>
+        </p:nvSpPr>
+        <p:spPr>
+          <a:xfrm>
+            <a:off x="640080" y="2194560"/>
+            <a:ext cx="11430000" cy="457200"/>
+          </a:xfrm>
+          <a:prstGeom prst="rect">
+            <a:avLst/>
+          </a:prstGeom>
+          <a:noFill/>
+        </p:spPr>
+        <p:txBody>
+          <a:bodyPr wrap="square" anchor="t">
+            <a:spAutoFit/>
+          </a:bodyPr>
+          <a:lstStyle/>
+          <a:p>
+            <a:pPr algn="l"/>
+            <a:r>
+              <a:rPr sz="1500" b="0">
                 <a:solidFill>
                   <a:srgbClr val="1A1A1A"/>
                 </a:solidFill>
-                <a:latin typeface="Calibri"/>
-              </a:rPr>
-              <a:t>• (2) κ structure under non-bounded output rubrics (graded relevance with longer scales, free-text rationales) may invert the within-family bounded-ordinal finding (C2)</a:t>
-            </a:r>
-          </a:p>
-          <a:p>
-            <a:pPr>
-              <a:lnSpc>
-                <a:spcPct val="130000"/>
-              </a:lnSpc>
-            </a:pPr>
-            <a:r>
-              <a:rPr sz="1700" b="0">
+                <a:latin typeface="Consolas"/>
+              </a:rPr>
+              <a:t>py eval_llm_judge.py --collection &lt;yours&gt; --judge-preset p4-supplement-openweight</a:t>
+            </a:r>
+          </a:p>
+        </p:txBody>
+      </p:sp>
+      <p:sp>
+        <p:nvSpPr>
+          <p:cNvPr id="6" name="TextBox 5"/>
+          <p:cNvSpPr txBox="1"/>
+          <p:nvPr/>
+        </p:nvSpPr>
+        <p:spPr>
+          <a:xfrm>
+            <a:off x="640080" y="2834640"/>
+            <a:ext cx="11430000" cy="457200"/>
+          </a:xfrm>
+          <a:prstGeom prst="rect">
+            <a:avLst/>
+          </a:prstGeom>
+          <a:noFill/>
+        </p:spPr>
+        <p:txBody>
+          <a:bodyPr wrap="square" anchor="t">
+            <a:spAutoFit/>
+          </a:bodyPr>
+          <a:lstStyle/>
+          <a:p>
+            <a:pPr algn="l"/>
+            <a:r>
+              <a:rPr sz="1800" b="1">
+                <a:solidFill>
+                  <a:srgbClr val="0E4A86"/>
+                </a:solidFill>
+                <a:latin typeface="Calibri"/>
+              </a:rPr>
+              <a:t>External-validation replication (~$35, ~7.5 h):</a:t>
+            </a:r>
+          </a:p>
+        </p:txBody>
+      </p:sp>
+      <p:sp>
+        <p:nvSpPr>
+          <p:cNvPr id="7" name="TextBox 6"/>
+          <p:cNvSpPr txBox="1"/>
+          <p:nvPr/>
+        </p:nvSpPr>
+        <p:spPr>
+          <a:xfrm>
+            <a:off x="640080" y="3337560"/>
+            <a:ext cx="11430000" cy="457200"/>
+          </a:xfrm>
+          <a:prstGeom prst="rect">
+            <a:avLst/>
+          </a:prstGeom>
+          <a:noFill/>
+        </p:spPr>
+        <p:txBody>
+          <a:bodyPr wrap="square" anchor="t">
+            <a:spAutoFit/>
+          </a:bodyPr>
+          <a:lstStyle/>
+          <a:p>
+            <a:pPr algn="l"/>
+            <a:r>
+              <a:rPr sz="1500" b="0">
                 <a:solidFill>
                   <a:srgbClr val="1A1A1A"/>
                 </a:solidFill>
-                <a:latin typeface="Calibri"/>
-              </a:rPr>
-              <a:t>• (3) Non-linear interactions in §6 mediation analysis (provider × reasoning) untested</a:t>
-            </a:r>
-          </a:p>
-          <a:p>
-            <a:pPr>
-              <a:lnSpc>
-                <a:spcPct val="130000"/>
-              </a:lnSpc>
-            </a:pPr>
-            <a:r>
-              <a:rPr sz="1700" b="0">
+                <a:latin typeface="Consolas"/>
+              </a:rPr>
+              <a:t>py validate_against_trec.py --corpus trec-rag-2024 --judge-preset p4-frontier --max-pairs 537</a:t>
+            </a:r>
+          </a:p>
+        </p:txBody>
+      </p:sp>
+      <p:sp>
+        <p:nvSpPr>
+          <p:cNvPr id="8" name="TextBox 7"/>
+          <p:cNvSpPr txBox="1"/>
+          <p:nvPr/>
+        </p:nvSpPr>
+        <p:spPr>
+          <a:xfrm>
+            <a:off x="640080" y="3749039"/>
+            <a:ext cx="11430000" cy="457200"/>
+          </a:xfrm>
+          <a:prstGeom prst="rect">
+            <a:avLst/>
+          </a:prstGeom>
+          <a:noFill/>
+        </p:spPr>
+        <p:txBody>
+          <a:bodyPr wrap="square" anchor="t">
+            <a:spAutoFit/>
+          </a:bodyPr>
+          <a:lstStyle/>
+          <a:p>
+            <a:pPr algn="l"/>
+            <a:r>
+              <a:rPr sz="1500" b="0">
                 <a:solidFill>
                   <a:srgbClr val="1A1A1A"/>
                 </a:solidFill>
-                <a:latin typeface="Calibri"/>
-              </a:rPr>
-              <a:t>• (4) Apples-to-apples replication of Thakur 2025's 537-pair subset pending receipt of their curated sample</a:t>
-            </a:r>
-          </a:p>
-          <a:p>
-            <a:pPr>
-              <a:lnSpc>
-                <a:spcPct val="130000"/>
-              </a:lnSpc>
-            </a:pPr>
-            <a:r>
-              <a:rPr sz="1700" b="0">
+                <a:latin typeface="Consolas"/>
+              </a:rPr>
+              <a:t>py validate_against_trec.py --corpus trec-rag-2024 --judge-preset p4-supplement-openweight --max-pairs 537</a:t>
+            </a:r>
+          </a:p>
+        </p:txBody>
+      </p:sp>
+      <p:sp>
+        <p:nvSpPr>
+          <p:cNvPr id="9" name="TextBox 8"/>
+          <p:cNvSpPr txBox="1"/>
+          <p:nvPr/>
+        </p:nvSpPr>
+        <p:spPr>
+          <a:xfrm>
+            <a:off x="640080" y="4160520"/>
+            <a:ext cx="11430000" cy="457200"/>
+          </a:xfrm>
+          <a:prstGeom prst="rect">
+            <a:avLst/>
+          </a:prstGeom>
+          <a:noFill/>
+        </p:spPr>
+        <p:txBody>
+          <a:bodyPr wrap="square" anchor="t">
+            <a:spAutoFit/>
+          </a:bodyPr>
+          <a:lstStyle/>
+          <a:p>
+            <a:pPr algn="l"/>
+            <a:r>
+              <a:rPr sz="1500" b="0">
                 <a:solidFill>
                   <a:srgbClr val="1A1A1A"/>
                 </a:solidFill>
-                <a:latin typeface="Calibri"/>
-              </a:rPr>
-              <a:t>• (5) TREC-COVID and LLMJudge benchmark validations deferred — TOIS journal-version extension</a:t>
-            </a:r>
-          </a:p>
-          <a:p>
-            <a:pPr>
-              <a:lnSpc>
-                <a:spcPct val="130000"/>
-              </a:lnSpc>
-            </a:pPr>
-            <a:r>
-              <a:rPr sz="1700" b="1">
-                <a:solidFill>
-                  <a:srgbClr val="1A1A1A"/>
-                </a:solidFill>
-                <a:latin typeface="Calibri"/>
-              </a:rPr>
-              <a:t>• (6) Cross-corpus mean κ on 4+ public benchmarks (vs 1 in current draft) for stronger generalization claim</a:t>
-            </a:r>
-          </a:p>
-        </p:txBody>
-      </p:sp>
-      <p:sp>
-        <p:nvSpPr>
-          <p:cNvPr id="4" name="TextBox 3"/>
+                <a:latin typeface="Consolas"/>
+              </a:rPr>
+              <a:t>py validate_against_trec.py --analyze trec-rag-2024</a:t>
+            </a:r>
+          </a:p>
+        </p:txBody>
+      </p:sp>
+      <p:sp>
+        <p:nvSpPr>
+          <p:cNvPr id="10" name="TextBox 9"/>
+          <p:cNvSpPr txBox="1"/>
+          <p:nvPr/>
+        </p:nvSpPr>
+        <p:spPr>
+          <a:xfrm>
+            <a:off x="640080" y="4937760"/>
+            <a:ext cx="11430000" cy="1371600"/>
+          </a:xfrm>
+          <a:prstGeom prst="rect">
+            <a:avLst/>
+          </a:prstGeom>
+          <a:noFill/>
+        </p:spPr>
+        <p:txBody>
+          <a:bodyPr wrap="square" anchor="t">
+            <a:spAutoFit/>
+          </a:bodyPr>
+          <a:lstStyle/>
+          <a:p>
+            <a:pPr algn="l"/>
+            <a:r>
+              <a:rPr sz="1300" b="0">
+                <a:solidFill>
+                  <a:srgbClr val="707070"/>
+                </a:solidFill>
+                <a:latin typeface="Calibri"/>
+              </a:rPr>
+              <a:t>Model versions pinned 2026-04-25: claude-opus-4-7, claude-sonnet-4-6, gpt-5.5, gpt-4o-2024-08-06, gemini-3.1-pro-preview, gemini-2.5-pro-2025-06-17, deepseek-v4-pro, qwen3.6-plus, gemma-4-26b-a4b-it. Target SIGIR Artifact Badging (Functional / Reusable).</a:t>
+            </a:r>
+          </a:p>
+        </p:txBody>
+      </p:sp>
+      <p:sp>
+        <p:nvSpPr>
+          <p:cNvPr id="11" name="TextBox 10"/>
           <p:cNvSpPr txBox="1"/>
           <p:nvPr/>
         </p:nvSpPr>
@@ -13377,7 +14410,7 @@
       </p:sp>
       <p:sp>
         <p:nvSpPr>
-          <p:cNvPr id="5" name="TextBox 4"/>
+          <p:cNvPr id="12" name="TextBox 11"/>
           <p:cNvSpPr txBox="1"/>
           <p:nvPr/>
         </p:nvSpPr>
@@ -13405,7 +14438,7 @@
                 </a:solidFill>
                 <a:latin typeface="Calibri"/>
               </a:rPr>
-              <a:t>30/32</a:t>
+              <a:t>30/33</a:t>
             </a:r>
           </a:p>
         </p:txBody>
@@ -13458,7 +14491,7 @@
                 </a:solidFill>
                 <a:latin typeface="Calibri"/>
               </a:rPr>
-              <a:t>Takeaway</a:t>
+              <a:t>Open questions for follow-up</a:t>
             </a:r>
           </a:p>
         </p:txBody>
@@ -13487,81 +14520,97 @@
           <a:p>
             <a:pPr>
               <a:lnSpc>
-                <a:spcPct val="135000"/>
+                <a:spcPct val="130000"/>
               </a:lnSpc>
             </a:pPr>
             <a:r>
-              <a:rPr sz="1800" b="1">
+              <a:rPr sz="1700" b="1">
                 <a:solidFill>
                   <a:srgbClr val="1A1A1A"/>
                 </a:solidFill>
                 <a:latin typeface="Calibri"/>
               </a:rPr>
-              <a:t>• CALIBRATION PHILOSOPHY (lenient vs strict score-allocation pattern), NOT provider lineage, is the axis on which retrieval verdicts shift</a:t>
+              <a:t>• (1) Cross-organization Qwen ↔ Gemma 4 convergence (κ=0.80) lacks complete mechanistic explanation — shared OSS research community? distillation lineage? compute regime? bounded-output prior?</a:t>
             </a:r>
           </a:p>
           <a:p>
             <a:pPr>
               <a:lnSpc>
-                <a:spcPct val="135000"/>
+                <a:spcPct val="130000"/>
               </a:lnSpc>
             </a:pPr>
             <a:r>
-              <a:rPr sz="1800" b="0">
+              <a:rPr sz="1700" b="0">
                 <a:solidFill>
                   <a:srgbClr val="1A1A1A"/>
                 </a:solidFill>
                 <a:latin typeface="Calibri"/>
               </a:rPr>
-              <a:t>• Cross-family agreement (κ ≥ 0.75) is high enough that judge interchangeability is a defensible default for reasoning-capable commercial judges</a:t>
+              <a:t>• (2) κ structure under non-bounded output rubrics (graded relevance with longer scales, free-text rationales) may invert the within-family bounded-ordinal finding (C2)</a:t>
             </a:r>
           </a:p>
           <a:p>
             <a:pPr>
               <a:lnSpc>
-                <a:spcPct val="135000"/>
+                <a:spcPct val="130000"/>
               </a:lnSpc>
             </a:pPr>
             <a:r>
-              <a:rPr sz="1800" b="1">
+              <a:rPr sz="1700" b="0">
                 <a:solidFill>
                   <a:srgbClr val="1A1A1A"/>
                 </a:solidFill>
                 <a:latin typeface="Calibri"/>
               </a:rPr>
-              <a:t>• Cross-organization open-weight ensemble (Qwen + Gemma 4) achieves matrix-highest κ at ~1% commercial cost — sovereign-cloud / on-prem deployments are NOT condemned to lower-quality judging</a:t>
+              <a:t>• (3) Non-linear interactions in §6 mediation analysis (provider × reasoning) untested</a:t>
             </a:r>
           </a:p>
           <a:p>
             <a:pPr>
               <a:lnSpc>
-                <a:spcPct val="135000"/>
+                <a:spcPct val="130000"/>
               </a:lnSpc>
             </a:pPr>
             <a:r>
-              <a:rPr sz="1800" b="0">
+              <a:rPr sz="1700" b="0">
                 <a:solidFill>
                   <a:srgbClr val="1A1A1A"/>
                 </a:solidFill>
                 <a:latin typeface="Calibri"/>
               </a:rPr>
-              <a:t>• External NIST validation (κ = 0.49 ensemble) confirms moderate-substantial agreement on a public IR benchmark</a:t>
+              <a:t>• (4) Apples-to-apples replication of Thakur 2025's 537-pair subset pending receipt of their curated sample</a:t>
             </a:r>
           </a:p>
           <a:p>
             <a:pPr>
               <a:lnSpc>
-                <a:spcPct val="135000"/>
+                <a:spcPct val="130000"/>
               </a:lnSpc>
             </a:pPr>
             <a:r>
-              <a:rPr sz="1800" b="1">
+              <a:rPr sz="1700" b="0">
                 <a:solidFill>
                   <a:srgbClr val="1A1A1A"/>
                 </a:solidFill>
                 <a:latin typeface="Calibri"/>
               </a:rPr>
-              <a:t>• Mechanism: 93% of pairwise κ variance is joint-distribution structure of paired scores — a NEW insight for ensemble design</a:t>
+              <a:t>• (5) TREC-COVID and LLMJudge benchmark validations deferred — TOIS journal-version extension</a:t>
+            </a:r>
+          </a:p>
+          <a:p>
+            <a:pPr>
+              <a:lnSpc>
+                <a:spcPct val="130000"/>
+              </a:lnSpc>
+            </a:pPr>
+            <a:r>
+              <a:rPr sz="1700" b="1">
+                <a:solidFill>
+                  <a:srgbClr val="1A1A1A"/>
+                </a:solidFill>
+                <a:latin typeface="Calibri"/>
+              </a:rPr>
+              <a:t>• (6) Cross-corpus mean κ on 4+ public benchmarks (vs 1 in current draft) for stronger generalization claim</a:t>
             </a:r>
           </a:p>
         </p:txBody>
@@ -13631,7 +14680,7 @@
                 </a:solidFill>
                 <a:latin typeface="Calibri"/>
               </a:rPr>
-              <a:t>31/32</a:t>
+              <a:t>31/33</a:t>
             </a:r>
           </a:p>
         </p:txBody>
@@ -13662,6 +14711,232 @@
         </p:nvSpPr>
         <p:spPr>
           <a:xfrm>
+            <a:off x="457200" y="320040"/>
+            <a:ext cx="11247120" cy="640080"/>
+          </a:xfrm>
+          <a:prstGeom prst="rect">
+            <a:avLst/>
+          </a:prstGeom>
+          <a:noFill/>
+        </p:spPr>
+        <p:txBody>
+          <a:bodyPr wrap="square" anchor="t">
+            <a:spAutoFit/>
+          </a:bodyPr>
+          <a:lstStyle/>
+          <a:p>
+            <a:pPr algn="l"/>
+            <a:r>
+              <a:rPr sz="3200" b="1">
+                <a:solidFill>
+                  <a:srgbClr val="0E4A86"/>
+                </a:solidFill>
+                <a:latin typeface="Calibri"/>
+              </a:rPr>
+              <a:t>Takeaway</a:t>
+            </a:r>
+          </a:p>
+        </p:txBody>
+      </p:sp>
+      <p:sp>
+        <p:nvSpPr>
+          <p:cNvPr id="3" name="TextBox 2"/>
+          <p:cNvSpPr txBox="1"/>
+          <p:nvPr/>
+        </p:nvSpPr>
+        <p:spPr>
+          <a:xfrm>
+            <a:off x="640080" y="1280160"/>
+            <a:ext cx="11430000" cy="4572000"/>
+          </a:xfrm>
+          <a:prstGeom prst="rect">
+            <a:avLst/>
+          </a:prstGeom>
+          <a:noFill/>
+        </p:spPr>
+        <p:txBody>
+          <a:bodyPr wrap="square">
+            <a:spAutoFit/>
+          </a:bodyPr>
+          <a:lstStyle/>
+          <a:p>
+            <a:pPr>
+              <a:lnSpc>
+                <a:spcPct val="135000"/>
+              </a:lnSpc>
+            </a:pPr>
+            <a:r>
+              <a:rPr sz="1800" b="1">
+                <a:solidFill>
+                  <a:srgbClr val="1A1A1A"/>
+                </a:solidFill>
+                <a:latin typeface="Calibri"/>
+              </a:rPr>
+              <a:t>• CALIBRATION PHILOSOPHY (lenient vs strict score-allocation pattern), NOT provider lineage, is the axis on which retrieval verdicts shift</a:t>
+            </a:r>
+          </a:p>
+          <a:p>
+            <a:pPr>
+              <a:lnSpc>
+                <a:spcPct val="135000"/>
+              </a:lnSpc>
+            </a:pPr>
+            <a:r>
+              <a:rPr sz="1800" b="0">
+                <a:solidFill>
+                  <a:srgbClr val="1A1A1A"/>
+                </a:solidFill>
+                <a:latin typeface="Calibri"/>
+              </a:rPr>
+              <a:t>• Cross-family agreement (κ ≥ 0.75) is high enough that judge interchangeability is a defensible default for reasoning-capable commercial judges</a:t>
+            </a:r>
+          </a:p>
+          <a:p>
+            <a:pPr>
+              <a:lnSpc>
+                <a:spcPct val="135000"/>
+              </a:lnSpc>
+            </a:pPr>
+            <a:r>
+              <a:rPr sz="1800" b="1">
+                <a:solidFill>
+                  <a:srgbClr val="1A1A1A"/>
+                </a:solidFill>
+                <a:latin typeface="Calibri"/>
+              </a:rPr>
+              <a:t>• Cross-organization open-weight ensemble (Qwen + Gemma 4) achieves matrix-highest κ at ~1% commercial cost — sovereign-cloud / on-prem deployments are NOT condemned to lower-quality judging</a:t>
+            </a:r>
+          </a:p>
+          <a:p>
+            <a:pPr>
+              <a:lnSpc>
+                <a:spcPct val="135000"/>
+              </a:lnSpc>
+            </a:pPr>
+            <a:r>
+              <a:rPr sz="1800" b="0">
+                <a:solidFill>
+                  <a:srgbClr val="1A1A1A"/>
+                </a:solidFill>
+                <a:latin typeface="Calibri"/>
+              </a:rPr>
+              <a:t>• External NIST validation (κ = 0.49 ensemble) confirms moderate-substantial agreement on a public IR benchmark</a:t>
+            </a:r>
+          </a:p>
+          <a:p>
+            <a:pPr>
+              <a:lnSpc>
+                <a:spcPct val="135000"/>
+              </a:lnSpc>
+            </a:pPr>
+            <a:r>
+              <a:rPr sz="1800" b="1">
+                <a:solidFill>
+                  <a:srgbClr val="1A1A1A"/>
+                </a:solidFill>
+                <a:latin typeface="Calibri"/>
+              </a:rPr>
+              <a:t>• Mechanism: 93% of pairwise κ variance is joint-distribution structure of paired scores — a NEW insight for ensemble design</a:t>
+            </a:r>
+          </a:p>
+        </p:txBody>
+      </p:sp>
+      <p:sp>
+        <p:nvSpPr>
+          <p:cNvPr id="4" name="TextBox 3"/>
+          <p:cNvSpPr txBox="1"/>
+          <p:nvPr/>
+        </p:nvSpPr>
+        <p:spPr>
+          <a:xfrm>
+            <a:off x="457200" y="6446520"/>
+            <a:ext cx="11247120" cy="274320"/>
+          </a:xfrm>
+          <a:prstGeom prst="rect">
+            <a:avLst/>
+          </a:prstGeom>
+          <a:noFill/>
+        </p:spPr>
+        <p:txBody>
+          <a:bodyPr wrap="square" anchor="t">
+            <a:spAutoFit/>
+          </a:bodyPr>
+          <a:lstStyle/>
+          <a:p>
+            <a:pPr algn="l"/>
+            <a:r>
+              <a:rPr sz="1000" b="0">
+                <a:solidFill>
+                  <a:srgbClr val="707070"/>
+                </a:solidFill>
+                <a:latin typeface="Calibri"/>
+              </a:rPr>
+              <a:t>P4 — LONG</a:t>
+            </a:r>
+          </a:p>
+        </p:txBody>
+      </p:sp>
+      <p:sp>
+        <p:nvSpPr>
+          <p:cNvPr id="5" name="TextBox 4"/>
+          <p:cNvSpPr txBox="1"/>
+          <p:nvPr/>
+        </p:nvSpPr>
+        <p:spPr>
+          <a:xfrm>
+            <a:off x="11430000" y="6446520"/>
+            <a:ext cx="640080" cy="274320"/>
+          </a:xfrm>
+          <a:prstGeom prst="rect">
+            <a:avLst/>
+          </a:prstGeom>
+          <a:noFill/>
+        </p:spPr>
+        <p:txBody>
+          <a:bodyPr wrap="square" anchor="t">
+            <a:spAutoFit/>
+          </a:bodyPr>
+          <a:lstStyle/>
+          <a:p>
+            <a:pPr algn="r"/>
+            <a:r>
+              <a:rPr sz="1000" b="0">
+                <a:solidFill>
+                  <a:srgbClr val="707070"/>
+                </a:solidFill>
+                <a:latin typeface="Calibri"/>
+              </a:rPr>
+              <a:t>32/33</a:t>
+            </a:r>
+          </a:p>
+        </p:txBody>
+      </p:sp>
+    </p:spTree>
+  </p:cSld>
+  <p:clrMapOvr>
+    <a:masterClrMapping/>
+  </p:clrMapOvr>
+</p:sld>
+</file>
+
+<file path=ppt/slides/slide33.xml><?xml version="1.0" encoding="utf-8"?>
+<p:sld xmlns:a="http://schemas.openxmlformats.org/drawingml/2006/main" xmlns:p="http://schemas.openxmlformats.org/presentationml/2006/main" xmlns:r="http://schemas.openxmlformats.org/officeDocument/2006/relationships">
+  <p:cSld>
+    <p:spTree>
+      <p:nvGrpSpPr>
+        <p:cNvPr id="1" name=""/>
+        <p:cNvGrpSpPr/>
+        <p:nvPr/>
+      </p:nvGrpSpPr>
+      <p:grpSpPr/>
+      <p:sp>
+        <p:nvSpPr>
+          <p:cNvPr id="2" name="TextBox 1"/>
+          <p:cNvSpPr txBox="1"/>
+          <p:nvPr/>
+        </p:nvSpPr>
+        <p:spPr>
+          <a:xfrm>
             <a:off x="914400" y="2286000"/>
             <a:ext cx="10332720" cy="1371600"/>
           </a:xfrm>
@@ -13754,7 +15029,7 @@
                 </a:solidFill>
                 <a:latin typeface="Calibri"/>
               </a:rPr>
-              <a:t>Code + data + paper draft: github.com/asukul/p4-llm-judge (forthcoming)</a:t>
+              <a:t>Code + data + paper draft: github.com/asukul/RAG-Eval-LLM-Judge</a:t>
             </a:r>
           </a:p>
         </p:txBody>
@@ -13824,7 +15099,7 @@
                 </a:solidFill>
                 <a:latin typeface="Calibri"/>
               </a:rPr>
-              <a:t>32/32</a:t>
+              <a:t>33/33</a:t>
             </a:r>
           </a:p>
         </p:txBody>
@@ -14101,7 +15376,7 @@
                 </a:solidFill>
                 <a:latin typeface="Calibri"/>
               </a:rPr>
-              <a:t>4/32</a:t>
+              <a:t>4/33</a:t>
             </a:r>
           </a:p>
         </p:txBody>
@@ -15107,7 +16382,7 @@
                 </a:solidFill>
                 <a:latin typeface="Calibri"/>
               </a:rPr>
-              <a:t>5/32</a:t>
+              <a:t>5/33</a:t>
             </a:r>
           </a:p>
         </p:txBody>
@@ -15365,7 +16640,7 @@
                 </a:solidFill>
                 <a:latin typeface="Calibri"/>
               </a:rPr>
-              <a:t>6/32</a:t>
+              <a:t>6/33</a:t>
             </a:r>
           </a:p>
         </p:txBody>
@@ -16722,7 +17997,7 @@
                 </a:solidFill>
                 <a:latin typeface="Calibri"/>
               </a:rPr>
-              <a:t>7/32</a:t>
+              <a:t>7/33</a:t>
             </a:r>
           </a:p>
         </p:txBody>
@@ -17262,7 +18537,7 @@
                 </a:solidFill>
                 <a:latin typeface="Calibri"/>
               </a:rPr>
-              <a:t>8/32</a:t>
+              <a:t>8/33</a:t>
             </a:r>
           </a:p>
         </p:txBody>
@@ -17409,7 +18684,7 @@
                 </a:solidFill>
                 <a:latin typeface="Calibri"/>
               </a:rPr>
-              <a:t>9/32</a:t>
+              <a:t>9/33</a:t>
             </a:r>
           </a:p>
         </p:txBody>

</xml_diff>